<commit_message>
Update file slide va talk script
</commit_message>
<xml_diff>
--- a/documents/slide bao cao.pptx
+++ b/documents/slide bao cao.pptx
@@ -5,7 +5,7 @@
     <p:sldMasterId id="2147483648" r:id="rId1"/>
   </p:sldMasterIdLst>
   <p:notesMasterIdLst>
-    <p:notesMasterId r:id="rId22"/>
+    <p:notesMasterId r:id="rId25"/>
   </p:notesMasterIdLst>
   <p:sldIdLst>
     <p:sldId id="256" r:id="rId2"/>
@@ -20,14 +20,17 @@
     <p:sldId id="276" r:id="rId11"/>
     <p:sldId id="264" r:id="rId12"/>
     <p:sldId id="265" r:id="rId13"/>
-    <p:sldId id="266" r:id="rId14"/>
-    <p:sldId id="260" r:id="rId15"/>
-    <p:sldId id="268" r:id="rId16"/>
-    <p:sldId id="269" r:id="rId17"/>
-    <p:sldId id="270" r:id="rId18"/>
-    <p:sldId id="271" r:id="rId19"/>
-    <p:sldId id="272" r:id="rId20"/>
-    <p:sldId id="273" r:id="rId21"/>
+    <p:sldId id="277" r:id="rId14"/>
+    <p:sldId id="279" r:id="rId15"/>
+    <p:sldId id="278" r:id="rId16"/>
+    <p:sldId id="266" r:id="rId17"/>
+    <p:sldId id="260" r:id="rId18"/>
+    <p:sldId id="268" r:id="rId19"/>
+    <p:sldId id="269" r:id="rId20"/>
+    <p:sldId id="270" r:id="rId21"/>
+    <p:sldId id="271" r:id="rId22"/>
+    <p:sldId id="272" r:id="rId23"/>
+    <p:sldId id="273" r:id="rId24"/>
   </p:sldIdLst>
   <p:sldSz cx="12192000" cy="6858000"/>
   <p:notesSz cx="6858000" cy="9144000"/>
@@ -216,7 +219,7 @@
           <a:p>
             <a:fld id="{AEB1C5C1-54CE-4892-A53C-9115FF4B63AE}" type="datetimeFigureOut">
               <a:rPr lang="en-US" smtClean="0"/>
-              <a:t>6/9/2025</a:t>
+              <a:t>6/10/2025</a:t>
             </a:fld>
             <a:endParaRPr lang="en-US"/>
           </a:p>
@@ -614,9 +617,63 @@
           <a:bodyPr/>
           <a:lstStyle/>
           <a:p>
-            <a:r>
-              <a:rPr lang="en-US"/>
-              <a:t>LLM</a:t>
+            <a:pPr marL="285750" indent="-285750">
+              <a:buFontTx/>
+              <a:buChar char="-"/>
+            </a:pPr>
+            <a:r>
+              <a:rPr lang="en-US"/>
+              <a:t>LLM là gì?</a:t>
+            </a:r>
+          </a:p>
+          <a:p>
+            <a:pPr marL="285750" indent="-285750">
+              <a:buFontTx/>
+              <a:buChar char="-"/>
+            </a:pPr>
+            <a:r>
+              <a:rPr lang="en-US"/>
+              <a:t>Tại sao lại gọi là LLM</a:t>
+            </a:r>
+          </a:p>
+          <a:p>
+            <a:pPr marL="285750" indent="-285750">
+              <a:buFontTx/>
+              <a:buChar char="-"/>
+            </a:pPr>
+            <a:r>
+              <a:rPr lang="en-US"/>
+              <a:t>Dựa trên nguyên lý? (xây dựng dựa trên transformer làm mô hình cơ sở, tuy nhiên thì có chút biến đổi)</a:t>
+            </a:r>
+          </a:p>
+          <a:p>
+            <a:pPr marL="285750" indent="-285750">
+              <a:buFontTx/>
+              <a:buChar char="-"/>
+            </a:pPr>
+            <a:r>
+              <a:rPr lang="en-US"/>
+              <a:t>Nó có thể làm gì? (sinh văn bản, xử lý âm thanh, video…)</a:t>
+            </a:r>
+          </a:p>
+          <a:p>
+            <a:pPr marL="285750" indent="-285750">
+              <a:buFontTx/>
+              <a:buChar char="-"/>
+            </a:pPr>
+            <a:r>
+              <a:rPr lang="en-US"/>
+              <a:t>Kể ra một vài thông số (LLM có thể lên tới hang tỉ tham số, chi phí huấn luyện khổng lồ, kiến trúc phức tạp)</a:t>
+            </a:r>
+          </a:p>
+          <a:p>
+            <a:pPr marL="285750" indent="-285750">
+              <a:buFontTx/>
+              <a:buChar char="-"/>
+            </a:pPr>
+            <a:r>
+              <a:rPr lang="en-US"/>
+              <a:t>chèn hình LLM</a:t>
             </a:r>
           </a:p>
         </p:txBody>
@@ -701,10 +758,57 @@
           <a:bodyPr/>
           <a:lstStyle/>
           <a:p>
-            <a:r>
-              <a:rPr lang="en-US"/>
-              <a:t>Word embedding</a:t>
-            </a:r>
+            <a:pPr marL="285750" indent="-285750">
+              <a:buFontTx/>
+              <a:buChar char="-"/>
+            </a:pPr>
+            <a:r>
+              <a:rPr lang="en-US"/>
+              <a:t>Hệ thống RAG là gì?</a:t>
+            </a:r>
+          </a:p>
+          <a:p>
+            <a:pPr marL="285750" indent="-285750">
+              <a:buFontTx/>
+              <a:buChar char="-"/>
+            </a:pPr>
+            <a:r>
+              <a:rPr lang="en-US"/>
+              <a:t>Tác dụng?</a:t>
+            </a:r>
+          </a:p>
+          <a:p>
+            <a:pPr marL="285750" indent="-285750">
+              <a:buFontTx/>
+              <a:buChar char="-"/>
+            </a:pPr>
+            <a:r>
+              <a:rPr lang="en-US"/>
+              <a:t>LLM được sử dụng trong hệ thống rag như thế nào?</a:t>
+            </a:r>
+          </a:p>
+          <a:p>
+            <a:pPr marL="285750" indent="-285750">
+              <a:buFontTx/>
+              <a:buChar char="-"/>
+            </a:pPr>
+            <a:r>
+              <a:rPr lang="en-US"/>
+              <a:t>Sử dụng LLM và hệ thống rag để xây dựng chatbot hõ trợ học lịch sử việt nam</a:t>
+            </a:r>
+          </a:p>
+          <a:p>
+            <a:pPr marL="285750" indent="-285750">
+              <a:buFontTx/>
+              <a:buChar char="-"/>
+            </a:pPr>
+            <a:r>
+              <a:rPr lang="en-US"/>
+              <a:t> (tại sao 2 cái đó lại có thể sử dụng để xây dung chatbot? Lợi tích so với các phương pháp truyền thống)</a:t>
+            </a:r>
+          </a:p>
+          <a:p>
+            <a:endParaRPr lang="en-US"/>
           </a:p>
         </p:txBody>
       </p:sp>
@@ -725,7 +829,410 @@
           <a:p>
             <a:fld id="{864AE1F8-3712-49A6-BC7C-273E12ADCFAB}" type="slidenum">
               <a:rPr lang="en-US" smtClean="0"/>
-              <a:t>14</a:t>
+              <a:t>5</a:t>
+            </a:fld>
+            <a:endParaRPr lang="en-US"/>
+          </a:p>
+        </p:txBody>
+      </p:sp>
+    </p:spTree>
+    <p:extLst>
+      <p:ext uri="{BB962C8B-B14F-4D97-AF65-F5344CB8AC3E}">
+        <p14:creationId xmlns:p14="http://schemas.microsoft.com/office/powerpoint/2010/main" val="1236781221"/>
+      </p:ext>
+    </p:extLst>
+  </p:cSld>
+  <p:clrMapOvr>
+    <a:masterClrMapping/>
+  </p:clrMapOvr>
+</p:notes>
+</file>
+
+<file path=ppt/notesSlides/notesSlide4.xml><?xml version="1.0" encoding="utf-8"?>
+<p:notes xmlns:a="http://schemas.openxmlformats.org/drawingml/2006/main" xmlns:r="http://schemas.openxmlformats.org/officeDocument/2006/relationships" xmlns:p="http://schemas.openxmlformats.org/presentationml/2006/main">
+  <p:cSld>
+    <p:spTree>
+      <p:nvGrpSpPr>
+        <p:cNvPr id="1" name=""/>
+        <p:cNvGrpSpPr/>
+        <p:nvPr/>
+      </p:nvGrpSpPr>
+      <p:grpSpPr>
+        <a:xfrm>
+          <a:off x="0" y="0"/>
+          <a:ext cx="0" cy="0"/>
+          <a:chOff x="0" y="0"/>
+          <a:chExt cx="0" cy="0"/>
+        </a:xfrm>
+      </p:grpSpPr>
+      <p:sp>
+        <p:nvSpPr>
+          <p:cNvPr id="2" name="Slide Image Placeholder 1"/>
+          <p:cNvSpPr>
+            <a:spLocks noGrp="1" noRot="1" noChangeAspect="1"/>
+          </p:cNvSpPr>
+          <p:nvPr>
+            <p:ph type="sldImg"/>
+          </p:nvPr>
+        </p:nvSpPr>
+        <p:spPr/>
+      </p:sp>
+      <p:sp>
+        <p:nvSpPr>
+          <p:cNvPr id="3" name="Notes Placeholder 2"/>
+          <p:cNvSpPr>
+            <a:spLocks noGrp="1"/>
+          </p:cNvSpPr>
+          <p:nvPr>
+            <p:ph type="body" idx="1"/>
+          </p:nvPr>
+        </p:nvSpPr>
+        <p:spPr/>
+        <p:txBody>
+          <a:bodyPr/>
+          <a:lstStyle/>
+          <a:p>
+            <a:pPr marL="285750" indent="-285750">
+              <a:buFontTx/>
+              <a:buChar char="-"/>
+            </a:pPr>
+            <a:r>
+              <a:rPr lang="en-US"/>
+              <a:t>Phương pháp đề xuất</a:t>
+            </a:r>
+          </a:p>
+          <a:p>
+            <a:pPr marL="285750" indent="-285750">
+              <a:buFontTx/>
+              <a:buChar char="-"/>
+            </a:pPr>
+            <a:r>
+              <a:rPr lang="en-US"/>
+              <a:t>Chèn hình, miêu tả chi tiết phương pháp đề xuất</a:t>
+            </a:r>
+          </a:p>
+          <a:p>
+            <a:pPr marL="0" indent="0">
+              <a:buFontTx/>
+              <a:buNone/>
+            </a:pPr>
+            <a:endParaRPr lang="en-US"/>
+          </a:p>
+        </p:txBody>
+      </p:sp>
+      <p:sp>
+        <p:nvSpPr>
+          <p:cNvPr id="4" name="Slide Number Placeholder 3"/>
+          <p:cNvSpPr>
+            <a:spLocks noGrp="1"/>
+          </p:cNvSpPr>
+          <p:nvPr>
+            <p:ph type="sldNum" sz="quarter" idx="5"/>
+          </p:nvPr>
+        </p:nvSpPr>
+        <p:spPr/>
+        <p:txBody>
+          <a:bodyPr/>
+          <a:lstStyle/>
+          <a:p>
+            <a:fld id="{864AE1F8-3712-49A6-BC7C-273E12ADCFAB}" type="slidenum">
+              <a:rPr lang="en-US" smtClean="0"/>
+              <a:t>8</a:t>
+            </a:fld>
+            <a:endParaRPr lang="en-US"/>
+          </a:p>
+        </p:txBody>
+      </p:sp>
+    </p:spTree>
+    <p:extLst>
+      <p:ext uri="{BB962C8B-B14F-4D97-AF65-F5344CB8AC3E}">
+        <p14:creationId xmlns:p14="http://schemas.microsoft.com/office/powerpoint/2010/main" val="2168959669"/>
+      </p:ext>
+    </p:extLst>
+  </p:cSld>
+  <p:clrMapOvr>
+    <a:masterClrMapping/>
+  </p:clrMapOvr>
+</p:notes>
+</file>
+
+<file path=ppt/notesSlides/notesSlide5.xml><?xml version="1.0" encoding="utf-8"?>
+<p:notes xmlns:a="http://schemas.openxmlformats.org/drawingml/2006/main" xmlns:r="http://schemas.openxmlformats.org/officeDocument/2006/relationships" xmlns:p="http://schemas.openxmlformats.org/presentationml/2006/main">
+  <p:cSld>
+    <p:spTree>
+      <p:nvGrpSpPr>
+        <p:cNvPr id="1" name=""/>
+        <p:cNvGrpSpPr/>
+        <p:nvPr/>
+      </p:nvGrpSpPr>
+      <p:grpSpPr>
+        <a:xfrm>
+          <a:off x="0" y="0"/>
+          <a:ext cx="0" cy="0"/>
+          <a:chOff x="0" y="0"/>
+          <a:chExt cx="0" cy="0"/>
+        </a:xfrm>
+      </p:grpSpPr>
+      <p:sp>
+        <p:nvSpPr>
+          <p:cNvPr id="2" name="Slide Image Placeholder 1"/>
+          <p:cNvSpPr>
+            <a:spLocks noGrp="1" noRot="1" noChangeAspect="1"/>
+          </p:cNvSpPr>
+          <p:nvPr>
+            <p:ph type="sldImg"/>
+          </p:nvPr>
+        </p:nvSpPr>
+        <p:spPr/>
+      </p:sp>
+      <p:sp>
+        <p:nvSpPr>
+          <p:cNvPr id="3" name="Notes Placeholder 2"/>
+          <p:cNvSpPr>
+            <a:spLocks noGrp="1"/>
+          </p:cNvSpPr>
+          <p:nvPr>
+            <p:ph type="body" idx="1"/>
+          </p:nvPr>
+        </p:nvSpPr>
+        <p:spPr/>
+        <p:txBody>
+          <a:bodyPr/>
+          <a:lstStyle/>
+          <a:p>
+            <a:pPr marL="0" marR="0" lvl="0" indent="0" algn="l" defTabSz="914400" rtl="0" eaLnBrk="1" fontAlgn="auto" latinLnBrk="0" hangingPunct="1">
+              <a:lnSpc>
+                <a:spcPct val="100000"/>
+              </a:lnSpc>
+              <a:spcBef>
+                <a:spcPts val="0"/>
+              </a:spcBef>
+              <a:spcAft>
+                <a:spcPts val="0"/>
+              </a:spcAft>
+              <a:buClrTx/>
+              <a:buSzTx/>
+              <a:buFontTx/>
+              <a:buNone/>
+              <a:tabLst/>
+              <a:defRPr/>
+            </a:pPr>
+            <a:r>
+              <a:rPr lang="en-US"/>
+              <a:t>Hệ thống rag đề xuất</a:t>
+            </a:r>
+          </a:p>
+          <a:p>
+            <a:endParaRPr lang="en-US"/>
+          </a:p>
+        </p:txBody>
+      </p:sp>
+      <p:sp>
+        <p:nvSpPr>
+          <p:cNvPr id="4" name="Slide Number Placeholder 3"/>
+          <p:cNvSpPr>
+            <a:spLocks noGrp="1"/>
+          </p:cNvSpPr>
+          <p:nvPr>
+            <p:ph type="sldNum" sz="quarter" idx="5"/>
+          </p:nvPr>
+        </p:nvSpPr>
+        <p:spPr/>
+        <p:txBody>
+          <a:bodyPr/>
+          <a:lstStyle/>
+          <a:p>
+            <a:fld id="{864AE1F8-3712-49A6-BC7C-273E12ADCFAB}" type="slidenum">
+              <a:rPr lang="en-US" smtClean="0"/>
+              <a:t>9</a:t>
+            </a:fld>
+            <a:endParaRPr lang="en-US"/>
+          </a:p>
+        </p:txBody>
+      </p:sp>
+    </p:spTree>
+    <p:extLst>
+      <p:ext uri="{BB962C8B-B14F-4D97-AF65-F5344CB8AC3E}">
+        <p14:creationId xmlns:p14="http://schemas.microsoft.com/office/powerpoint/2010/main" val="2689238879"/>
+      </p:ext>
+    </p:extLst>
+  </p:cSld>
+  <p:clrMapOvr>
+    <a:masterClrMapping/>
+  </p:clrMapOvr>
+</p:notes>
+</file>
+
+<file path=ppt/notesSlides/notesSlide6.xml><?xml version="1.0" encoding="utf-8"?>
+<p:notes xmlns:a="http://schemas.openxmlformats.org/drawingml/2006/main" xmlns:r="http://schemas.openxmlformats.org/officeDocument/2006/relationships" xmlns:p="http://schemas.openxmlformats.org/presentationml/2006/main">
+  <p:cSld>
+    <p:spTree>
+      <p:nvGrpSpPr>
+        <p:cNvPr id="1" name=""/>
+        <p:cNvGrpSpPr/>
+        <p:nvPr/>
+      </p:nvGrpSpPr>
+      <p:grpSpPr>
+        <a:xfrm>
+          <a:off x="0" y="0"/>
+          <a:ext cx="0" cy="0"/>
+          <a:chOff x="0" y="0"/>
+          <a:chExt cx="0" cy="0"/>
+        </a:xfrm>
+      </p:grpSpPr>
+      <p:sp>
+        <p:nvSpPr>
+          <p:cNvPr id="2" name="Slide Image Placeholder 1"/>
+          <p:cNvSpPr>
+            <a:spLocks noGrp="1" noRot="1" noChangeAspect="1"/>
+          </p:cNvSpPr>
+          <p:nvPr>
+            <p:ph type="sldImg"/>
+          </p:nvPr>
+        </p:nvSpPr>
+        <p:spPr/>
+      </p:sp>
+      <p:sp>
+        <p:nvSpPr>
+          <p:cNvPr id="3" name="Notes Placeholder 2"/>
+          <p:cNvSpPr>
+            <a:spLocks noGrp="1"/>
+          </p:cNvSpPr>
+          <p:nvPr>
+            <p:ph type="body" idx="1"/>
+          </p:nvPr>
+        </p:nvSpPr>
+        <p:spPr/>
+        <p:txBody>
+          <a:bodyPr/>
+          <a:lstStyle/>
+          <a:p>
+            <a:pPr marL="285750" indent="-285750">
+              <a:buFontTx/>
+              <a:buChar char="-"/>
+            </a:pPr>
+            <a:r>
+              <a:rPr lang="en-US"/>
+              <a:t>Thu thập và tiền xử lý data</a:t>
+            </a:r>
+          </a:p>
+          <a:p>
+            <a:pPr marL="285750" indent="-285750">
+              <a:buFontTx/>
+              <a:buChar char="-"/>
+            </a:pPr>
+            <a:endParaRPr lang="en-US"/>
+          </a:p>
+          <a:p>
+            <a:endParaRPr lang="en-US"/>
+          </a:p>
+        </p:txBody>
+      </p:sp>
+      <p:sp>
+        <p:nvSpPr>
+          <p:cNvPr id="4" name="Slide Number Placeholder 3"/>
+          <p:cNvSpPr>
+            <a:spLocks noGrp="1"/>
+          </p:cNvSpPr>
+          <p:nvPr>
+            <p:ph type="sldNum" sz="quarter" idx="5"/>
+          </p:nvPr>
+        </p:nvSpPr>
+        <p:spPr/>
+        <p:txBody>
+          <a:bodyPr/>
+          <a:lstStyle/>
+          <a:p>
+            <a:fld id="{864AE1F8-3712-49A6-BC7C-273E12ADCFAB}" type="slidenum">
+              <a:rPr lang="en-US" smtClean="0"/>
+              <a:t>11</a:t>
+            </a:fld>
+            <a:endParaRPr lang="en-US"/>
+          </a:p>
+        </p:txBody>
+      </p:sp>
+    </p:spTree>
+    <p:extLst>
+      <p:ext uri="{BB962C8B-B14F-4D97-AF65-F5344CB8AC3E}">
+        <p14:creationId xmlns:p14="http://schemas.microsoft.com/office/powerpoint/2010/main" val="4011839683"/>
+      </p:ext>
+    </p:extLst>
+  </p:cSld>
+  <p:clrMapOvr>
+    <a:masterClrMapping/>
+  </p:clrMapOvr>
+</p:notes>
+</file>
+
+<file path=ppt/notesSlides/notesSlide7.xml><?xml version="1.0" encoding="utf-8"?>
+<p:notes xmlns:a="http://schemas.openxmlformats.org/drawingml/2006/main" xmlns:r="http://schemas.openxmlformats.org/officeDocument/2006/relationships" xmlns:p="http://schemas.openxmlformats.org/presentationml/2006/main">
+  <p:cSld>
+    <p:spTree>
+      <p:nvGrpSpPr>
+        <p:cNvPr id="1" name=""/>
+        <p:cNvGrpSpPr/>
+        <p:nvPr/>
+      </p:nvGrpSpPr>
+      <p:grpSpPr>
+        <a:xfrm>
+          <a:off x="0" y="0"/>
+          <a:ext cx="0" cy="0"/>
+          <a:chOff x="0" y="0"/>
+          <a:chExt cx="0" cy="0"/>
+        </a:xfrm>
+      </p:grpSpPr>
+      <p:sp>
+        <p:nvSpPr>
+          <p:cNvPr id="2" name="Slide Image Placeholder 1"/>
+          <p:cNvSpPr>
+            <a:spLocks noGrp="1" noRot="1" noChangeAspect="1"/>
+          </p:cNvSpPr>
+          <p:nvPr>
+            <p:ph type="sldImg"/>
+          </p:nvPr>
+        </p:nvSpPr>
+        <p:spPr/>
+      </p:sp>
+      <p:sp>
+        <p:nvSpPr>
+          <p:cNvPr id="3" name="Notes Placeholder 2"/>
+          <p:cNvSpPr>
+            <a:spLocks noGrp="1"/>
+          </p:cNvSpPr>
+          <p:nvPr>
+            <p:ph type="body" idx="1"/>
+          </p:nvPr>
+        </p:nvSpPr>
+        <p:spPr/>
+        <p:txBody>
+          <a:bodyPr/>
+          <a:lstStyle/>
+          <a:p>
+            <a:r>
+              <a:rPr lang="en-US"/>
+              <a:t>Word embedding</a:t>
+            </a:r>
+          </a:p>
+        </p:txBody>
+      </p:sp>
+      <p:sp>
+        <p:nvSpPr>
+          <p:cNvPr id="4" name="Slide Number Placeholder 3"/>
+          <p:cNvSpPr>
+            <a:spLocks noGrp="1"/>
+          </p:cNvSpPr>
+          <p:nvPr>
+            <p:ph type="sldNum" sz="quarter" idx="5"/>
+          </p:nvPr>
+        </p:nvSpPr>
+        <p:spPr/>
+        <p:txBody>
+          <a:bodyPr/>
+          <a:lstStyle/>
+          <a:p>
+            <a:fld id="{864AE1F8-3712-49A6-BC7C-273E12ADCFAB}" type="slidenum">
+              <a:rPr lang="en-US" smtClean="0"/>
+              <a:t>17</a:t>
             </a:fld>
             <a:endParaRPr lang="en-US"/>
           </a:p>
@@ -891,7 +1398,7 @@
           <a:p>
             <a:fld id="{AC66C343-037B-4BB6-A079-7472CF8881D5}" type="datetimeFigureOut">
               <a:rPr lang="en-US" smtClean="0"/>
-              <a:t>6/9/2025</a:t>
+              <a:t>6/10/2025</a:t>
             </a:fld>
             <a:endParaRPr lang="en-US"/>
           </a:p>
@@ -1089,7 +1596,7 @@
           <a:p>
             <a:fld id="{AC66C343-037B-4BB6-A079-7472CF8881D5}" type="datetimeFigureOut">
               <a:rPr lang="en-US" smtClean="0"/>
-              <a:t>6/9/2025</a:t>
+              <a:t>6/10/2025</a:t>
             </a:fld>
             <a:endParaRPr lang="en-US"/>
           </a:p>
@@ -1297,7 +1804,7 @@
           <a:p>
             <a:fld id="{AC66C343-037B-4BB6-A079-7472CF8881D5}" type="datetimeFigureOut">
               <a:rPr lang="en-US" smtClean="0"/>
-              <a:t>6/9/2025</a:t>
+              <a:t>6/10/2025</a:t>
             </a:fld>
             <a:endParaRPr lang="en-US"/>
           </a:p>
@@ -1495,7 +2002,7 @@
           <a:p>
             <a:fld id="{AC66C343-037B-4BB6-A079-7472CF8881D5}" type="datetimeFigureOut">
               <a:rPr lang="en-US" smtClean="0"/>
-              <a:t>6/9/2025</a:t>
+              <a:t>6/10/2025</a:t>
             </a:fld>
             <a:endParaRPr lang="en-US"/>
           </a:p>
@@ -1770,7 +2277,7 @@
           <a:p>
             <a:fld id="{AC66C343-037B-4BB6-A079-7472CF8881D5}" type="datetimeFigureOut">
               <a:rPr lang="en-US" smtClean="0"/>
-              <a:t>6/9/2025</a:t>
+              <a:t>6/10/2025</a:t>
             </a:fld>
             <a:endParaRPr lang="en-US"/>
           </a:p>
@@ -2035,7 +2542,7 @@
           <a:p>
             <a:fld id="{AC66C343-037B-4BB6-A079-7472CF8881D5}" type="datetimeFigureOut">
               <a:rPr lang="en-US" smtClean="0"/>
-              <a:t>6/9/2025</a:t>
+              <a:t>6/10/2025</a:t>
             </a:fld>
             <a:endParaRPr lang="en-US"/>
           </a:p>
@@ -2447,7 +2954,7 @@
           <a:p>
             <a:fld id="{AC66C343-037B-4BB6-A079-7472CF8881D5}" type="datetimeFigureOut">
               <a:rPr lang="en-US" smtClean="0"/>
-              <a:t>6/9/2025</a:t>
+              <a:t>6/10/2025</a:t>
             </a:fld>
             <a:endParaRPr lang="en-US"/>
           </a:p>
@@ -2588,7 +3095,7 @@
           <a:p>
             <a:fld id="{AC66C343-037B-4BB6-A079-7472CF8881D5}" type="datetimeFigureOut">
               <a:rPr lang="en-US" smtClean="0"/>
-              <a:t>6/9/2025</a:t>
+              <a:t>6/10/2025</a:t>
             </a:fld>
             <a:endParaRPr lang="en-US"/>
           </a:p>
@@ -2701,7 +3208,7 @@
           <a:p>
             <a:fld id="{AC66C343-037B-4BB6-A079-7472CF8881D5}" type="datetimeFigureOut">
               <a:rPr lang="en-US" smtClean="0"/>
-              <a:t>6/9/2025</a:t>
+              <a:t>6/10/2025</a:t>
             </a:fld>
             <a:endParaRPr lang="en-US"/>
           </a:p>
@@ -3012,7 +3519,7 @@
           <a:p>
             <a:fld id="{AC66C343-037B-4BB6-A079-7472CF8881D5}" type="datetimeFigureOut">
               <a:rPr lang="en-US" smtClean="0"/>
-              <a:t>6/9/2025</a:t>
+              <a:t>6/10/2025</a:t>
             </a:fld>
             <a:endParaRPr lang="en-US"/>
           </a:p>
@@ -3300,7 +3807,7 @@
           <a:p>
             <a:fld id="{AC66C343-037B-4BB6-A079-7472CF8881D5}" type="datetimeFigureOut">
               <a:rPr lang="en-US" smtClean="0"/>
-              <a:t>6/9/2025</a:t>
+              <a:t>6/10/2025</a:t>
             </a:fld>
             <a:endParaRPr lang="en-US"/>
           </a:p>
@@ -3541,7 +4048,7 @@
           <a:p>
             <a:fld id="{AC66C343-037B-4BB6-A079-7472CF8881D5}" type="datetimeFigureOut">
               <a:rPr lang="en-US" smtClean="0"/>
-              <a:t>6/9/2025</a:t>
+              <a:t>6/10/2025</a:t>
             </a:fld>
             <a:endParaRPr lang="en-US"/>
           </a:p>
@@ -4133,52 +4640,42 @@
           <a:chExt cx="0" cy="0"/>
         </a:xfrm>
       </p:grpSpPr>
-      <p:sp>
-        <p:nvSpPr>
-          <p:cNvPr id="2" name="TextBox 1">
-            <a:extLst>
-              <a:ext uri="{FF2B5EF4-FFF2-40B4-BE49-F238E27FC236}">
-                <a16:creationId xmlns:a16="http://schemas.microsoft.com/office/drawing/2014/main" id="{269FD35E-AD92-3EF5-13C8-5B290E78C311}"/>
-              </a:ext>
-            </a:extLst>
-          </p:cNvPr>
-          <p:cNvSpPr txBox="1"/>
+      <p:pic>
+        <p:nvPicPr>
+          <p:cNvPr id="4" name="Picture 3" descr="A black background with red lines&#10;&#10;AI-generated content may be incorrect.">
+            <a:extLst>
+              <a:ext uri="{FF2B5EF4-FFF2-40B4-BE49-F238E27FC236}">
+                <a16:creationId xmlns:a16="http://schemas.microsoft.com/office/drawing/2014/main" id="{3633D7FF-B793-8A53-A482-E4D42B1F0408}"/>
+              </a:ext>
+            </a:extLst>
+          </p:cNvPr>
+          <p:cNvPicPr>
+            <a:picLocks noChangeAspect="1"/>
+          </p:cNvPicPr>
           <p:nvPr/>
-        </p:nvSpPr>
+        </p:nvPicPr>
+        <p:blipFill>
+          <a:blip r:embed="rId3">
+            <a:extLst>
+              <a:ext uri="{28A0092B-C50C-407E-A947-70E740481C1C}">
+                <a14:useLocalDpi xmlns:a14="http://schemas.microsoft.com/office/drawing/2010/main" val="0"/>
+              </a:ext>
+            </a:extLst>
+          </a:blip>
+          <a:stretch>
+            <a:fillRect/>
+          </a:stretch>
+        </p:blipFill>
         <p:spPr>
           <a:xfrm>
-            <a:off x="2571750" y="2667000"/>
-            <a:ext cx="3031856" cy="646331"/>
+            <a:off x="0" y="165538"/>
+            <a:ext cx="8248773" cy="3263462"/>
           </a:xfrm>
           <a:prstGeom prst="rect">
             <a:avLst/>
           </a:prstGeom>
-          <a:noFill/>
         </p:spPr>
-        <p:txBody>
-          <a:bodyPr wrap="none" rtlCol="0">
-            <a:spAutoFit/>
-          </a:bodyPr>
-          <a:lstStyle/>
-          <a:p>
-            <a:pPr marL="285750" indent="-285750">
-              <a:buFontTx/>
-              <a:buChar char="-"/>
-            </a:pPr>
-            <a:r>
-              <a:rPr lang="en-US"/>
-              <a:t>Thu thập và tiền xử lý data</a:t>
-            </a:r>
-          </a:p>
-          <a:p>
-            <a:pPr marL="285750" indent="-285750">
-              <a:buFontTx/>
-              <a:buChar char="-"/>
-            </a:pPr>
-            <a:endParaRPr lang="en-US"/>
-          </a:p>
-        </p:txBody>
-      </p:sp>
+      </p:pic>
     </p:spTree>
     <p:extLst>
       <p:ext uri="{BB962C8B-B14F-4D97-AF65-F5344CB8AC3E}">
@@ -4331,13 +4828,7 @@
   <p:cSld>
     <p:spTree>
       <p:nvGrpSpPr>
-        <p:cNvPr id="1" name="">
-          <a:extLst>
-            <a:ext uri="{FF2B5EF4-FFF2-40B4-BE49-F238E27FC236}">
-              <a16:creationId xmlns:a16="http://schemas.microsoft.com/office/drawing/2014/main" id="{3C3204C1-5F08-5680-957D-395D6D1D7918}"/>
-            </a:ext>
-          </a:extLst>
-        </p:cNvPr>
+        <p:cNvPr id="1" name=""/>
         <p:cNvGrpSpPr/>
         <p:nvPr/>
       </p:nvGrpSpPr>
@@ -4349,108 +4840,10 @@
           <a:chExt cx="0" cy="0"/>
         </a:xfrm>
       </p:grpSpPr>
-      <p:sp>
-        <p:nvSpPr>
-          <p:cNvPr id="2" name="TextBox 1">
-            <a:extLst>
-              <a:ext uri="{FF2B5EF4-FFF2-40B4-BE49-F238E27FC236}">
-                <a16:creationId xmlns:a16="http://schemas.microsoft.com/office/drawing/2014/main" id="{764BCB41-73FC-CD7C-9D26-CEE00D05CB5B}"/>
-              </a:ext>
-            </a:extLst>
-          </p:cNvPr>
-          <p:cNvSpPr txBox="1"/>
-          <p:nvPr/>
-        </p:nvSpPr>
-        <p:spPr>
-          <a:xfrm>
-            <a:off x="2571750" y="2667000"/>
-            <a:ext cx="5783699" cy="2308324"/>
-          </a:xfrm>
-          <a:prstGeom prst="rect">
-            <a:avLst/>
-          </a:prstGeom>
-          <a:noFill/>
-        </p:spPr>
-        <p:txBody>
-          <a:bodyPr wrap="none" rtlCol="0">
-            <a:spAutoFit/>
-          </a:bodyPr>
-          <a:lstStyle/>
-          <a:p>
-            <a:r>
-              <a:rPr lang="en-US"/>
-              <a:t>embedding data:</a:t>
-            </a:r>
-          </a:p>
-          <a:p>
-            <a:pPr marL="285750" indent="-285750">
-              <a:buFontTx/>
-              <a:buChar char="-"/>
-            </a:pPr>
-            <a:r>
-              <a:rPr lang="en-US"/>
-              <a:t>giới thiệu word embedding là gì?</a:t>
-            </a:r>
-          </a:p>
-          <a:p>
-            <a:pPr marL="285750" indent="-285750">
-              <a:buFontTx/>
-              <a:buChar char="-"/>
-            </a:pPr>
-            <a:r>
-              <a:rPr lang="en-US"/>
-              <a:t>Tại sao, Lợi tích</a:t>
-            </a:r>
-          </a:p>
-          <a:p>
-            <a:pPr marL="285750" indent="-285750">
-              <a:buFontTx/>
-              <a:buChar char="-"/>
-            </a:pPr>
-            <a:endParaRPr lang="en-US"/>
-          </a:p>
-          <a:p>
-            <a:r>
-              <a:rPr lang="en-US"/>
-              <a:t>các mô hình embedding đề xuất:</a:t>
-            </a:r>
-          </a:p>
-          <a:p>
-            <a:pPr marL="285750" indent="-285750">
-              <a:buFontTx/>
-              <a:buChar char="-"/>
-            </a:pPr>
-            <a:r>
-              <a:rPr lang="en-US"/>
-              <a:t>liệt kê các mô hình + kèm thông số</a:t>
-            </a:r>
-          </a:p>
-          <a:p>
-            <a:pPr marL="285750" indent="-285750">
-              <a:buFontTx/>
-              <a:buChar char="-"/>
-            </a:pPr>
-            <a:r>
-              <a:rPr lang="en-US"/>
-              <a:t>Đánh giá hiệu quả tokenization của model embedding</a:t>
-            </a:r>
-          </a:p>
-          <a:p>
-            <a:pPr marL="285750" indent="-285750">
-              <a:buFontTx/>
-              <a:buChar char="-"/>
-            </a:pPr>
-            <a:r>
-              <a:rPr lang="en-US"/>
-              <a:t>Đánh giá hiệu quả embedding data</a:t>
-            </a:r>
-          </a:p>
-        </p:txBody>
-      </p:sp>
     </p:spTree>
     <p:extLst>
       <p:ext uri="{BB962C8B-B14F-4D97-AF65-F5344CB8AC3E}">
-        <p14:creationId xmlns:p14="http://schemas.microsoft.com/office/powerpoint/2010/main" val="661741629"/>
+        <p14:creationId xmlns:p14="http://schemas.microsoft.com/office/powerpoint/2010/main" val="970251462"/>
       </p:ext>
     </p:extLst>
   </p:cSld>
@@ -4477,6 +4870,200 @@
           <a:chExt cx="0" cy="0"/>
         </a:xfrm>
       </p:grpSpPr>
+    </p:spTree>
+    <p:extLst>
+      <p:ext uri="{BB962C8B-B14F-4D97-AF65-F5344CB8AC3E}">
+        <p14:creationId xmlns:p14="http://schemas.microsoft.com/office/powerpoint/2010/main" val="196680871"/>
+      </p:ext>
+    </p:extLst>
+  </p:cSld>
+  <p:clrMapOvr>
+    <a:masterClrMapping/>
+  </p:clrMapOvr>
+</p:sld>
+</file>
+
+<file path=ppt/slides/slide15.xml><?xml version="1.0" encoding="utf-8"?>
+<p:sld xmlns:a="http://schemas.openxmlformats.org/drawingml/2006/main" xmlns:r="http://schemas.openxmlformats.org/officeDocument/2006/relationships" xmlns:p="http://schemas.openxmlformats.org/presentationml/2006/main">
+  <p:cSld>
+    <p:spTree>
+      <p:nvGrpSpPr>
+        <p:cNvPr id="1" name=""/>
+        <p:cNvGrpSpPr/>
+        <p:nvPr/>
+      </p:nvGrpSpPr>
+      <p:grpSpPr>
+        <a:xfrm>
+          <a:off x="0" y="0"/>
+          <a:ext cx="0" cy="0"/>
+          <a:chOff x="0" y="0"/>
+          <a:chExt cx="0" cy="0"/>
+        </a:xfrm>
+      </p:grpSpPr>
+    </p:spTree>
+    <p:extLst>
+      <p:ext uri="{BB962C8B-B14F-4D97-AF65-F5344CB8AC3E}">
+        <p14:creationId xmlns:p14="http://schemas.microsoft.com/office/powerpoint/2010/main" val="3943545070"/>
+      </p:ext>
+    </p:extLst>
+  </p:cSld>
+  <p:clrMapOvr>
+    <a:masterClrMapping/>
+  </p:clrMapOvr>
+</p:sld>
+</file>
+
+<file path=ppt/slides/slide16.xml><?xml version="1.0" encoding="utf-8"?>
+<p:sld xmlns:a="http://schemas.openxmlformats.org/drawingml/2006/main" xmlns:r="http://schemas.openxmlformats.org/officeDocument/2006/relationships" xmlns:p="http://schemas.openxmlformats.org/presentationml/2006/main">
+  <p:cSld>
+    <p:spTree>
+      <p:nvGrpSpPr>
+        <p:cNvPr id="1" name="">
+          <a:extLst>
+            <a:ext uri="{FF2B5EF4-FFF2-40B4-BE49-F238E27FC236}">
+              <a16:creationId xmlns:a16="http://schemas.microsoft.com/office/drawing/2014/main" id="{3C3204C1-5F08-5680-957D-395D6D1D7918}"/>
+            </a:ext>
+          </a:extLst>
+        </p:cNvPr>
+        <p:cNvGrpSpPr/>
+        <p:nvPr/>
+      </p:nvGrpSpPr>
+      <p:grpSpPr>
+        <a:xfrm>
+          <a:off x="0" y="0"/>
+          <a:ext cx="0" cy="0"/>
+          <a:chOff x="0" y="0"/>
+          <a:chExt cx="0" cy="0"/>
+        </a:xfrm>
+      </p:grpSpPr>
+      <p:sp>
+        <p:nvSpPr>
+          <p:cNvPr id="2" name="TextBox 1">
+            <a:extLst>
+              <a:ext uri="{FF2B5EF4-FFF2-40B4-BE49-F238E27FC236}">
+                <a16:creationId xmlns:a16="http://schemas.microsoft.com/office/drawing/2014/main" id="{764BCB41-73FC-CD7C-9D26-CEE00D05CB5B}"/>
+              </a:ext>
+            </a:extLst>
+          </p:cNvPr>
+          <p:cNvSpPr txBox="1"/>
+          <p:nvPr/>
+        </p:nvSpPr>
+        <p:spPr>
+          <a:xfrm>
+            <a:off x="2571750" y="2667000"/>
+            <a:ext cx="5783699" cy="2308324"/>
+          </a:xfrm>
+          <a:prstGeom prst="rect">
+            <a:avLst/>
+          </a:prstGeom>
+          <a:noFill/>
+        </p:spPr>
+        <p:txBody>
+          <a:bodyPr wrap="none" rtlCol="0">
+            <a:spAutoFit/>
+          </a:bodyPr>
+          <a:lstStyle/>
+          <a:p>
+            <a:r>
+              <a:rPr lang="en-US"/>
+              <a:t>embedding data:</a:t>
+            </a:r>
+          </a:p>
+          <a:p>
+            <a:pPr marL="285750" indent="-285750">
+              <a:buFontTx/>
+              <a:buChar char="-"/>
+            </a:pPr>
+            <a:r>
+              <a:rPr lang="en-US"/>
+              <a:t>giới thiệu word embedding là gì?</a:t>
+            </a:r>
+          </a:p>
+          <a:p>
+            <a:pPr marL="285750" indent="-285750">
+              <a:buFontTx/>
+              <a:buChar char="-"/>
+            </a:pPr>
+            <a:r>
+              <a:rPr lang="en-US"/>
+              <a:t>Tại sao, Lợi tích</a:t>
+            </a:r>
+          </a:p>
+          <a:p>
+            <a:pPr marL="285750" indent="-285750">
+              <a:buFontTx/>
+              <a:buChar char="-"/>
+            </a:pPr>
+            <a:endParaRPr lang="en-US"/>
+          </a:p>
+          <a:p>
+            <a:r>
+              <a:rPr lang="en-US"/>
+              <a:t>các mô hình embedding đề xuất:</a:t>
+            </a:r>
+          </a:p>
+          <a:p>
+            <a:pPr marL="285750" indent="-285750">
+              <a:buFontTx/>
+              <a:buChar char="-"/>
+            </a:pPr>
+            <a:r>
+              <a:rPr lang="en-US"/>
+              <a:t>liệt kê các mô hình + kèm thông số</a:t>
+            </a:r>
+          </a:p>
+          <a:p>
+            <a:pPr marL="285750" indent="-285750">
+              <a:buFontTx/>
+              <a:buChar char="-"/>
+            </a:pPr>
+            <a:r>
+              <a:rPr lang="en-US"/>
+              <a:t>Đánh giá hiệu quả tokenization của model embedding</a:t>
+            </a:r>
+          </a:p>
+          <a:p>
+            <a:pPr marL="285750" indent="-285750">
+              <a:buFontTx/>
+              <a:buChar char="-"/>
+            </a:pPr>
+            <a:r>
+              <a:rPr lang="en-US"/>
+              <a:t>Đánh giá hiệu quả embedding data</a:t>
+            </a:r>
+          </a:p>
+        </p:txBody>
+      </p:sp>
+    </p:spTree>
+    <p:extLst>
+      <p:ext uri="{BB962C8B-B14F-4D97-AF65-F5344CB8AC3E}">
+        <p14:creationId xmlns:p14="http://schemas.microsoft.com/office/powerpoint/2010/main" val="661741629"/>
+      </p:ext>
+    </p:extLst>
+  </p:cSld>
+  <p:clrMapOvr>
+    <a:masterClrMapping/>
+  </p:clrMapOvr>
+</p:sld>
+</file>
+
+<file path=ppt/slides/slide17.xml><?xml version="1.0" encoding="utf-8"?>
+<p:sld xmlns:a="http://schemas.openxmlformats.org/drawingml/2006/main" xmlns:r="http://schemas.openxmlformats.org/officeDocument/2006/relationships" xmlns:p="http://schemas.openxmlformats.org/presentationml/2006/main">
+  <p:cSld>
+    <p:spTree>
+      <p:nvGrpSpPr>
+        <p:cNvPr id="1" name=""/>
+        <p:cNvGrpSpPr/>
+        <p:nvPr/>
+      </p:nvGrpSpPr>
+      <p:grpSpPr>
+        <a:xfrm>
+          <a:off x="0" y="0"/>
+          <a:ext cx="0" cy="0"/>
+          <a:chOff x="0" y="0"/>
+          <a:chExt cx="0" cy="0"/>
+        </a:xfrm>
+      </p:grpSpPr>
       <p:pic>
         <p:nvPicPr>
           <p:cNvPr id="3" name="Picture 2" descr="A diagram of words and numbers&#10;&#10;AI-generated content may be incorrect.">
@@ -4580,7 +5167,7 @@
 </p:sld>
 </file>
 
-<file path=ppt/slides/slide15.xml><?xml version="1.0" encoding="utf-8"?>
+<file path=ppt/slides/slide18.xml><?xml version="1.0" encoding="utf-8"?>
 <p:sld xmlns:a="http://schemas.openxmlformats.org/drawingml/2006/main" xmlns:r="http://schemas.openxmlformats.org/officeDocument/2006/relationships" xmlns:p="http://schemas.openxmlformats.org/presentationml/2006/main">
   <p:cSld>
     <p:spTree>
@@ -4678,7 +5265,7 @@
 </p:sld>
 </file>
 
-<file path=ppt/slides/slide16.xml><?xml version="1.0" encoding="utf-8"?>
+<file path=ppt/slides/slide19.xml><?xml version="1.0" encoding="utf-8"?>
 <p:sld xmlns:a="http://schemas.openxmlformats.org/drawingml/2006/main" xmlns:r="http://schemas.openxmlformats.org/officeDocument/2006/relationships" xmlns:p="http://schemas.openxmlformats.org/presentationml/2006/main">
   <p:cSld>
     <p:spTree>
@@ -4746,277 +5333,6 @@
     <p:extLst>
       <p:ext uri="{BB962C8B-B14F-4D97-AF65-F5344CB8AC3E}">
         <p14:creationId xmlns:p14="http://schemas.microsoft.com/office/powerpoint/2010/main" val="1391973288"/>
-      </p:ext>
-    </p:extLst>
-  </p:cSld>
-  <p:clrMapOvr>
-    <a:masterClrMapping/>
-  </p:clrMapOvr>
-</p:sld>
-</file>
-
-<file path=ppt/slides/slide17.xml><?xml version="1.0" encoding="utf-8"?>
-<p:sld xmlns:a="http://schemas.openxmlformats.org/drawingml/2006/main" xmlns:r="http://schemas.openxmlformats.org/officeDocument/2006/relationships" xmlns:p="http://schemas.openxmlformats.org/presentationml/2006/main">
-  <p:cSld>
-    <p:spTree>
-      <p:nvGrpSpPr>
-        <p:cNvPr id="1" name="">
-          <a:extLst>
-            <a:ext uri="{FF2B5EF4-FFF2-40B4-BE49-F238E27FC236}">
-              <a16:creationId xmlns:a16="http://schemas.microsoft.com/office/drawing/2014/main" id="{CE9B43E1-6279-1E12-7C4D-079661226798}"/>
-            </a:ext>
-          </a:extLst>
-        </p:cNvPr>
-        <p:cNvGrpSpPr/>
-        <p:nvPr/>
-      </p:nvGrpSpPr>
-      <p:grpSpPr>
-        <a:xfrm>
-          <a:off x="0" y="0"/>
-          <a:ext cx="0" cy="0"/>
-          <a:chOff x="0" y="0"/>
-          <a:chExt cx="0" cy="0"/>
-        </a:xfrm>
-      </p:grpSpPr>
-      <p:sp>
-        <p:nvSpPr>
-          <p:cNvPr id="2" name="TextBox 1">
-            <a:extLst>
-              <a:ext uri="{FF2B5EF4-FFF2-40B4-BE49-F238E27FC236}">
-                <a16:creationId xmlns:a16="http://schemas.microsoft.com/office/drawing/2014/main" id="{AA4A9EF1-8662-93B5-1E75-CA2964560939}"/>
-              </a:ext>
-            </a:extLst>
-          </p:cNvPr>
-          <p:cNvSpPr txBox="1"/>
-          <p:nvPr/>
-        </p:nvSpPr>
-        <p:spPr>
-          <a:xfrm>
-            <a:off x="2571750" y="2667000"/>
-            <a:ext cx="2916568" cy="369332"/>
-          </a:xfrm>
-          <a:prstGeom prst="rect">
-            <a:avLst/>
-          </a:prstGeom>
-          <a:noFill/>
-        </p:spPr>
-        <p:txBody>
-          <a:bodyPr wrap="none" rtlCol="0">
-            <a:spAutoFit/>
-          </a:bodyPr>
-          <a:lstStyle/>
-          <a:p>
-            <a:r>
-              <a:rPr lang="en-US"/>
-              <a:t>Chức năng chatbot văn bản</a:t>
-            </a:r>
-          </a:p>
-        </p:txBody>
-      </p:sp>
-    </p:spTree>
-    <p:extLst>
-      <p:ext uri="{BB962C8B-B14F-4D97-AF65-F5344CB8AC3E}">
-        <p14:creationId xmlns:p14="http://schemas.microsoft.com/office/powerpoint/2010/main" val="540094921"/>
-      </p:ext>
-    </p:extLst>
-  </p:cSld>
-  <p:clrMapOvr>
-    <a:masterClrMapping/>
-  </p:clrMapOvr>
-</p:sld>
-</file>
-
-<file path=ppt/slides/slide18.xml><?xml version="1.0" encoding="utf-8"?>
-<p:sld xmlns:a="http://schemas.openxmlformats.org/drawingml/2006/main" xmlns:r="http://schemas.openxmlformats.org/officeDocument/2006/relationships" xmlns:p="http://schemas.openxmlformats.org/presentationml/2006/main">
-  <p:cSld>
-    <p:spTree>
-      <p:nvGrpSpPr>
-        <p:cNvPr id="1" name="">
-          <a:extLst>
-            <a:ext uri="{FF2B5EF4-FFF2-40B4-BE49-F238E27FC236}">
-              <a16:creationId xmlns:a16="http://schemas.microsoft.com/office/drawing/2014/main" id="{D730F8F1-2303-4AC4-E099-3DF21445E9D9}"/>
-            </a:ext>
-          </a:extLst>
-        </p:cNvPr>
-        <p:cNvGrpSpPr/>
-        <p:nvPr/>
-      </p:nvGrpSpPr>
-      <p:grpSpPr>
-        <a:xfrm>
-          <a:off x="0" y="0"/>
-          <a:ext cx="0" cy="0"/>
-          <a:chOff x="0" y="0"/>
-          <a:chExt cx="0" cy="0"/>
-        </a:xfrm>
-      </p:grpSpPr>
-      <p:sp>
-        <p:nvSpPr>
-          <p:cNvPr id="2" name="TextBox 1">
-            <a:extLst>
-              <a:ext uri="{FF2B5EF4-FFF2-40B4-BE49-F238E27FC236}">
-                <a16:creationId xmlns:a16="http://schemas.microsoft.com/office/drawing/2014/main" id="{DC579DB5-FB17-6D49-7A4D-2B764E003DC2}"/>
-              </a:ext>
-            </a:extLst>
-          </p:cNvPr>
-          <p:cNvSpPr txBox="1"/>
-          <p:nvPr/>
-        </p:nvSpPr>
-        <p:spPr>
-          <a:xfrm>
-            <a:off x="457200" y="1657350"/>
-            <a:ext cx="10203242" cy="2031325"/>
-          </a:xfrm>
-          <a:prstGeom prst="rect">
-            <a:avLst/>
-          </a:prstGeom>
-          <a:noFill/>
-        </p:spPr>
-        <p:txBody>
-          <a:bodyPr wrap="none" rtlCol="0">
-            <a:spAutoFit/>
-          </a:bodyPr>
-          <a:lstStyle/>
-          <a:p>
-            <a:r>
-              <a:rPr lang="en-US"/>
-              <a:t>Chức năng trò chuyện thời gian thực</a:t>
-            </a:r>
-          </a:p>
-          <a:p>
-            <a:r>
-              <a:rPr lang="en-US"/>
-              <a:t>Giới thiệu về công nghệ TTS-STT</a:t>
-            </a:r>
-          </a:p>
-          <a:p>
-            <a:pPr marL="285750" indent="-285750">
-              <a:buFontTx/>
-              <a:buChar char="-"/>
-            </a:pPr>
-            <a:r>
-              <a:rPr lang="en-US"/>
-              <a:t>giới thiệu</a:t>
-            </a:r>
-          </a:p>
-          <a:p>
-            <a:pPr marL="285750" indent="-285750">
-              <a:buFontTx/>
-              <a:buChar char="-"/>
-            </a:pPr>
-            <a:r>
-              <a:rPr lang="en-US"/>
-              <a:t>Lợi tích</a:t>
-            </a:r>
-          </a:p>
-          <a:p>
-            <a:pPr marL="285750" indent="-285750">
-              <a:buFontTx/>
-              <a:buChar char="-"/>
-            </a:pPr>
-            <a:r>
-              <a:rPr lang="en-US"/>
-              <a:t>Lợi tích khi Ứng dụng công nghệ này vào hệ thống chatbot</a:t>
-            </a:r>
-          </a:p>
-          <a:p>
-            <a:pPr marL="285750" indent="-285750">
-              <a:buFontTx/>
-              <a:buChar char="-"/>
-            </a:pPr>
-            <a:r>
-              <a:rPr lang="en-US"/>
-              <a:t>Phương pháp triển khai hệ thống (miêu tả hệ thống  hoạt động như thế nào? Cách mà văn bản được</a:t>
-            </a:r>
-          </a:p>
-          <a:p>
-            <a:r>
-              <a:rPr lang="en-US"/>
-              <a:t>Chuyển thành âm thanh và ngược lại. (chi tiết các phần và luồng hoạt động để sau)</a:t>
-            </a:r>
-          </a:p>
-        </p:txBody>
-      </p:sp>
-    </p:spTree>
-    <p:extLst>
-      <p:ext uri="{BB962C8B-B14F-4D97-AF65-F5344CB8AC3E}">
-        <p14:creationId xmlns:p14="http://schemas.microsoft.com/office/powerpoint/2010/main" val="3712810268"/>
-      </p:ext>
-    </p:extLst>
-  </p:cSld>
-  <p:clrMapOvr>
-    <a:masterClrMapping/>
-  </p:clrMapOvr>
-</p:sld>
-</file>
-
-<file path=ppt/slides/slide19.xml><?xml version="1.0" encoding="utf-8"?>
-<p:sld xmlns:a="http://schemas.openxmlformats.org/drawingml/2006/main" xmlns:r="http://schemas.openxmlformats.org/officeDocument/2006/relationships" xmlns:p="http://schemas.openxmlformats.org/presentationml/2006/main">
-  <p:cSld>
-    <p:spTree>
-      <p:nvGrpSpPr>
-        <p:cNvPr id="1" name="">
-          <a:extLst>
-            <a:ext uri="{FF2B5EF4-FFF2-40B4-BE49-F238E27FC236}">
-              <a16:creationId xmlns:a16="http://schemas.microsoft.com/office/drawing/2014/main" id="{E69FDD86-2554-20C0-3BD8-48C3D0CE3EE9}"/>
-            </a:ext>
-          </a:extLst>
-        </p:cNvPr>
-        <p:cNvGrpSpPr/>
-        <p:nvPr/>
-      </p:nvGrpSpPr>
-      <p:grpSpPr>
-        <a:xfrm>
-          <a:off x="0" y="0"/>
-          <a:ext cx="0" cy="0"/>
-          <a:chOff x="0" y="0"/>
-          <a:chExt cx="0" cy="0"/>
-        </a:xfrm>
-      </p:grpSpPr>
-      <p:sp>
-        <p:nvSpPr>
-          <p:cNvPr id="2" name="TextBox 1">
-            <a:extLst>
-              <a:ext uri="{FF2B5EF4-FFF2-40B4-BE49-F238E27FC236}">
-                <a16:creationId xmlns:a16="http://schemas.microsoft.com/office/drawing/2014/main" id="{3C5E1B44-3531-38D8-BE32-5BD8B7E04216}"/>
-              </a:ext>
-            </a:extLst>
-          </p:cNvPr>
-          <p:cNvSpPr txBox="1"/>
-          <p:nvPr/>
-        </p:nvSpPr>
-        <p:spPr>
-          <a:xfrm>
-            <a:off x="457200" y="1657350"/>
-            <a:ext cx="5905078" cy="646331"/>
-          </a:xfrm>
-          <a:prstGeom prst="rect">
-            <a:avLst/>
-          </a:prstGeom>
-          <a:noFill/>
-        </p:spPr>
-        <p:txBody>
-          <a:bodyPr wrap="none" rtlCol="0">
-            <a:spAutoFit/>
-          </a:bodyPr>
-          <a:lstStyle/>
-          <a:p>
-            <a:r>
-              <a:rPr lang="en-US"/>
-              <a:t>Quá trình sinh phản hồi</a:t>
-            </a:r>
-          </a:p>
-          <a:p>
-            <a:r>
-              <a:rPr lang="en-US"/>
-              <a:t>Đề cập đến data được embedding và retrieval như thế nào</a:t>
-            </a:r>
-          </a:p>
-        </p:txBody>
-      </p:sp>
-    </p:spTree>
-    <p:extLst>
-      <p:ext uri="{BB962C8B-B14F-4D97-AF65-F5344CB8AC3E}">
-        <p14:creationId xmlns:p14="http://schemas.microsoft.com/office/powerpoint/2010/main" val="755535105"/>
       </p:ext>
     </p:extLst>
   </p:cSld>
@@ -5116,6 +5432,277 @@
 </file>
 
 <file path=ppt/slides/slide20.xml><?xml version="1.0" encoding="utf-8"?>
+<p:sld xmlns:a="http://schemas.openxmlformats.org/drawingml/2006/main" xmlns:r="http://schemas.openxmlformats.org/officeDocument/2006/relationships" xmlns:p="http://schemas.openxmlformats.org/presentationml/2006/main">
+  <p:cSld>
+    <p:spTree>
+      <p:nvGrpSpPr>
+        <p:cNvPr id="1" name="">
+          <a:extLst>
+            <a:ext uri="{FF2B5EF4-FFF2-40B4-BE49-F238E27FC236}">
+              <a16:creationId xmlns:a16="http://schemas.microsoft.com/office/drawing/2014/main" id="{CE9B43E1-6279-1E12-7C4D-079661226798}"/>
+            </a:ext>
+          </a:extLst>
+        </p:cNvPr>
+        <p:cNvGrpSpPr/>
+        <p:nvPr/>
+      </p:nvGrpSpPr>
+      <p:grpSpPr>
+        <a:xfrm>
+          <a:off x="0" y="0"/>
+          <a:ext cx="0" cy="0"/>
+          <a:chOff x="0" y="0"/>
+          <a:chExt cx="0" cy="0"/>
+        </a:xfrm>
+      </p:grpSpPr>
+      <p:sp>
+        <p:nvSpPr>
+          <p:cNvPr id="2" name="TextBox 1">
+            <a:extLst>
+              <a:ext uri="{FF2B5EF4-FFF2-40B4-BE49-F238E27FC236}">
+                <a16:creationId xmlns:a16="http://schemas.microsoft.com/office/drawing/2014/main" id="{AA4A9EF1-8662-93B5-1E75-CA2964560939}"/>
+              </a:ext>
+            </a:extLst>
+          </p:cNvPr>
+          <p:cNvSpPr txBox="1"/>
+          <p:nvPr/>
+        </p:nvSpPr>
+        <p:spPr>
+          <a:xfrm>
+            <a:off x="2571750" y="2667000"/>
+            <a:ext cx="2916568" cy="369332"/>
+          </a:xfrm>
+          <a:prstGeom prst="rect">
+            <a:avLst/>
+          </a:prstGeom>
+          <a:noFill/>
+        </p:spPr>
+        <p:txBody>
+          <a:bodyPr wrap="none" rtlCol="0">
+            <a:spAutoFit/>
+          </a:bodyPr>
+          <a:lstStyle/>
+          <a:p>
+            <a:r>
+              <a:rPr lang="en-US"/>
+              <a:t>Chức năng chatbot văn bản</a:t>
+            </a:r>
+          </a:p>
+        </p:txBody>
+      </p:sp>
+    </p:spTree>
+    <p:extLst>
+      <p:ext uri="{BB962C8B-B14F-4D97-AF65-F5344CB8AC3E}">
+        <p14:creationId xmlns:p14="http://schemas.microsoft.com/office/powerpoint/2010/main" val="540094921"/>
+      </p:ext>
+    </p:extLst>
+  </p:cSld>
+  <p:clrMapOvr>
+    <a:masterClrMapping/>
+  </p:clrMapOvr>
+</p:sld>
+</file>
+
+<file path=ppt/slides/slide21.xml><?xml version="1.0" encoding="utf-8"?>
+<p:sld xmlns:a="http://schemas.openxmlformats.org/drawingml/2006/main" xmlns:r="http://schemas.openxmlformats.org/officeDocument/2006/relationships" xmlns:p="http://schemas.openxmlformats.org/presentationml/2006/main">
+  <p:cSld>
+    <p:spTree>
+      <p:nvGrpSpPr>
+        <p:cNvPr id="1" name="">
+          <a:extLst>
+            <a:ext uri="{FF2B5EF4-FFF2-40B4-BE49-F238E27FC236}">
+              <a16:creationId xmlns:a16="http://schemas.microsoft.com/office/drawing/2014/main" id="{D730F8F1-2303-4AC4-E099-3DF21445E9D9}"/>
+            </a:ext>
+          </a:extLst>
+        </p:cNvPr>
+        <p:cNvGrpSpPr/>
+        <p:nvPr/>
+      </p:nvGrpSpPr>
+      <p:grpSpPr>
+        <a:xfrm>
+          <a:off x="0" y="0"/>
+          <a:ext cx="0" cy="0"/>
+          <a:chOff x="0" y="0"/>
+          <a:chExt cx="0" cy="0"/>
+        </a:xfrm>
+      </p:grpSpPr>
+      <p:sp>
+        <p:nvSpPr>
+          <p:cNvPr id="2" name="TextBox 1">
+            <a:extLst>
+              <a:ext uri="{FF2B5EF4-FFF2-40B4-BE49-F238E27FC236}">
+                <a16:creationId xmlns:a16="http://schemas.microsoft.com/office/drawing/2014/main" id="{DC579DB5-FB17-6D49-7A4D-2B764E003DC2}"/>
+              </a:ext>
+            </a:extLst>
+          </p:cNvPr>
+          <p:cNvSpPr txBox="1"/>
+          <p:nvPr/>
+        </p:nvSpPr>
+        <p:spPr>
+          <a:xfrm>
+            <a:off x="457200" y="1657350"/>
+            <a:ext cx="10203242" cy="2031325"/>
+          </a:xfrm>
+          <a:prstGeom prst="rect">
+            <a:avLst/>
+          </a:prstGeom>
+          <a:noFill/>
+        </p:spPr>
+        <p:txBody>
+          <a:bodyPr wrap="none" rtlCol="0">
+            <a:spAutoFit/>
+          </a:bodyPr>
+          <a:lstStyle/>
+          <a:p>
+            <a:r>
+              <a:rPr lang="en-US"/>
+              <a:t>Chức năng trò chuyện thời gian thực</a:t>
+            </a:r>
+          </a:p>
+          <a:p>
+            <a:r>
+              <a:rPr lang="en-US"/>
+              <a:t>Giới thiệu về công nghệ TTS-STT</a:t>
+            </a:r>
+          </a:p>
+          <a:p>
+            <a:pPr marL="285750" indent="-285750">
+              <a:buFontTx/>
+              <a:buChar char="-"/>
+            </a:pPr>
+            <a:r>
+              <a:rPr lang="en-US"/>
+              <a:t>giới thiệu</a:t>
+            </a:r>
+          </a:p>
+          <a:p>
+            <a:pPr marL="285750" indent="-285750">
+              <a:buFontTx/>
+              <a:buChar char="-"/>
+            </a:pPr>
+            <a:r>
+              <a:rPr lang="en-US"/>
+              <a:t>Lợi tích</a:t>
+            </a:r>
+          </a:p>
+          <a:p>
+            <a:pPr marL="285750" indent="-285750">
+              <a:buFontTx/>
+              <a:buChar char="-"/>
+            </a:pPr>
+            <a:r>
+              <a:rPr lang="en-US"/>
+              <a:t>Lợi tích khi Ứng dụng công nghệ này vào hệ thống chatbot</a:t>
+            </a:r>
+          </a:p>
+          <a:p>
+            <a:pPr marL="285750" indent="-285750">
+              <a:buFontTx/>
+              <a:buChar char="-"/>
+            </a:pPr>
+            <a:r>
+              <a:rPr lang="en-US"/>
+              <a:t>Phương pháp triển khai hệ thống (miêu tả hệ thống  hoạt động như thế nào? Cách mà văn bản được</a:t>
+            </a:r>
+          </a:p>
+          <a:p>
+            <a:r>
+              <a:rPr lang="en-US"/>
+              <a:t>Chuyển thành âm thanh và ngược lại. (chi tiết các phần và luồng hoạt động để sau)</a:t>
+            </a:r>
+          </a:p>
+        </p:txBody>
+      </p:sp>
+    </p:spTree>
+    <p:extLst>
+      <p:ext uri="{BB962C8B-B14F-4D97-AF65-F5344CB8AC3E}">
+        <p14:creationId xmlns:p14="http://schemas.microsoft.com/office/powerpoint/2010/main" val="3712810268"/>
+      </p:ext>
+    </p:extLst>
+  </p:cSld>
+  <p:clrMapOvr>
+    <a:masterClrMapping/>
+  </p:clrMapOvr>
+</p:sld>
+</file>
+
+<file path=ppt/slides/slide22.xml><?xml version="1.0" encoding="utf-8"?>
+<p:sld xmlns:a="http://schemas.openxmlformats.org/drawingml/2006/main" xmlns:r="http://schemas.openxmlformats.org/officeDocument/2006/relationships" xmlns:p="http://schemas.openxmlformats.org/presentationml/2006/main">
+  <p:cSld>
+    <p:spTree>
+      <p:nvGrpSpPr>
+        <p:cNvPr id="1" name="">
+          <a:extLst>
+            <a:ext uri="{FF2B5EF4-FFF2-40B4-BE49-F238E27FC236}">
+              <a16:creationId xmlns:a16="http://schemas.microsoft.com/office/drawing/2014/main" id="{E69FDD86-2554-20C0-3BD8-48C3D0CE3EE9}"/>
+            </a:ext>
+          </a:extLst>
+        </p:cNvPr>
+        <p:cNvGrpSpPr/>
+        <p:nvPr/>
+      </p:nvGrpSpPr>
+      <p:grpSpPr>
+        <a:xfrm>
+          <a:off x="0" y="0"/>
+          <a:ext cx="0" cy="0"/>
+          <a:chOff x="0" y="0"/>
+          <a:chExt cx="0" cy="0"/>
+        </a:xfrm>
+      </p:grpSpPr>
+      <p:sp>
+        <p:nvSpPr>
+          <p:cNvPr id="2" name="TextBox 1">
+            <a:extLst>
+              <a:ext uri="{FF2B5EF4-FFF2-40B4-BE49-F238E27FC236}">
+                <a16:creationId xmlns:a16="http://schemas.microsoft.com/office/drawing/2014/main" id="{3C5E1B44-3531-38D8-BE32-5BD8B7E04216}"/>
+              </a:ext>
+            </a:extLst>
+          </p:cNvPr>
+          <p:cNvSpPr txBox="1"/>
+          <p:nvPr/>
+        </p:nvSpPr>
+        <p:spPr>
+          <a:xfrm>
+            <a:off x="457200" y="1657350"/>
+            <a:ext cx="5905078" cy="646331"/>
+          </a:xfrm>
+          <a:prstGeom prst="rect">
+            <a:avLst/>
+          </a:prstGeom>
+          <a:noFill/>
+        </p:spPr>
+        <p:txBody>
+          <a:bodyPr wrap="none" rtlCol="0">
+            <a:spAutoFit/>
+          </a:bodyPr>
+          <a:lstStyle/>
+          <a:p>
+            <a:r>
+              <a:rPr lang="en-US"/>
+              <a:t>Quá trình sinh phản hồi</a:t>
+            </a:r>
+          </a:p>
+          <a:p>
+            <a:r>
+              <a:rPr lang="en-US"/>
+              <a:t>Đề cập đến data được embedding và retrieval như thế nào</a:t>
+            </a:r>
+          </a:p>
+        </p:txBody>
+      </p:sp>
+    </p:spTree>
+    <p:extLst>
+      <p:ext uri="{BB962C8B-B14F-4D97-AF65-F5344CB8AC3E}">
+        <p14:creationId xmlns:p14="http://schemas.microsoft.com/office/powerpoint/2010/main" val="755535105"/>
+      </p:ext>
+    </p:extLst>
+  </p:cSld>
+  <p:clrMapOvr>
+    <a:masterClrMapping/>
+  </p:clrMapOvr>
+</p:sld>
+</file>
+
+<file path=ppt/slides/slide23.xml><?xml version="1.0" encoding="utf-8"?>
 <p:sld xmlns:a="http://schemas.openxmlformats.org/drawingml/2006/main" xmlns:r="http://schemas.openxmlformats.org/officeDocument/2006/relationships" xmlns:p="http://schemas.openxmlformats.org/presentationml/2006/main">
   <p:cSld>
     <p:spTree>
@@ -5170,1245 +5757,6 @@
       </p:grpSpPr>
       <p:sp>
         <p:nvSpPr>
-          <p:cNvPr id="2" name="Arrow: Right 1">
-            <a:extLst>
-              <a:ext uri="{FF2B5EF4-FFF2-40B4-BE49-F238E27FC236}">
-                <a16:creationId xmlns:a16="http://schemas.microsoft.com/office/drawing/2014/main" id="{3880489C-52F7-148C-C3B0-FD58332F9695}"/>
-              </a:ext>
-            </a:extLst>
-          </p:cNvPr>
-          <p:cNvSpPr/>
-          <p:nvPr/>
-        </p:nvSpPr>
-        <p:spPr>
-          <a:xfrm>
-            <a:off x="639097" y="3274142"/>
-            <a:ext cx="10913806" cy="309716"/>
-          </a:xfrm>
-          <a:prstGeom prst="rightArrow">
-            <a:avLst/>
-          </a:prstGeom>
-        </p:spPr>
-        <p:style>
-          <a:lnRef idx="1">
-            <a:schemeClr val="accent2"/>
-          </a:lnRef>
-          <a:fillRef idx="2">
-            <a:schemeClr val="accent2"/>
-          </a:fillRef>
-          <a:effectRef idx="1">
-            <a:schemeClr val="accent2"/>
-          </a:effectRef>
-          <a:fontRef idx="minor">
-            <a:schemeClr val="dk1"/>
-          </a:fontRef>
-        </p:style>
-        <p:txBody>
-          <a:bodyPr rtlCol="0" anchor="ctr"/>
-          <a:lstStyle/>
-          <a:p>
-            <a:pPr algn="ctr"/>
-            <a:endParaRPr lang="en-US"/>
-          </a:p>
-        </p:txBody>
-      </p:sp>
-      <p:sp>
-        <p:nvSpPr>
-          <p:cNvPr id="6" name="Oval 5">
-            <a:extLst>
-              <a:ext uri="{FF2B5EF4-FFF2-40B4-BE49-F238E27FC236}">
-                <a16:creationId xmlns:a16="http://schemas.microsoft.com/office/drawing/2014/main" id="{5AF77646-F02A-1A12-74F6-1F582274C5BE}"/>
-              </a:ext>
-            </a:extLst>
-          </p:cNvPr>
-          <p:cNvSpPr/>
-          <p:nvPr/>
-        </p:nvSpPr>
-        <p:spPr>
-          <a:xfrm>
-            <a:off x="1275987" y="3270045"/>
-            <a:ext cx="309716" cy="309716"/>
-          </a:xfrm>
-          <a:prstGeom prst="ellipse">
-            <a:avLst/>
-          </a:prstGeom>
-        </p:spPr>
-        <p:style>
-          <a:lnRef idx="2">
-            <a:schemeClr val="dk1">
-              <a:shade val="15000"/>
-            </a:schemeClr>
-          </a:lnRef>
-          <a:fillRef idx="1">
-            <a:schemeClr val="dk1"/>
-          </a:fillRef>
-          <a:effectRef idx="0">
-            <a:schemeClr val="dk1"/>
-          </a:effectRef>
-          <a:fontRef idx="minor">
-            <a:schemeClr val="lt1"/>
-          </a:fontRef>
-        </p:style>
-        <p:txBody>
-          <a:bodyPr rtlCol="0" anchor="ctr"/>
-          <a:lstStyle/>
-          <a:p>
-            <a:pPr algn="ctr"/>
-            <a:endParaRPr lang="en-US"/>
-          </a:p>
-        </p:txBody>
-      </p:sp>
-      <p:cxnSp>
-        <p:nvCxnSpPr>
-          <p:cNvPr id="8" name="Straight Connector 7">
-            <a:extLst>
-              <a:ext uri="{FF2B5EF4-FFF2-40B4-BE49-F238E27FC236}">
-                <a16:creationId xmlns:a16="http://schemas.microsoft.com/office/drawing/2014/main" id="{F027B7A9-9009-E676-2765-D30EEB891E4C}"/>
-              </a:ext>
-            </a:extLst>
-          </p:cNvPr>
-          <p:cNvCxnSpPr>
-            <a:cxnSpLocks/>
-            <a:stCxn id="6" idx="4"/>
-          </p:cNvCxnSpPr>
-          <p:nvPr/>
-        </p:nvCxnSpPr>
-        <p:spPr>
-          <a:xfrm flipH="1">
-            <a:off x="1425666" y="3579761"/>
-            <a:ext cx="5179" cy="861142"/>
-          </a:xfrm>
-          <a:prstGeom prst="line">
-            <a:avLst/>
-          </a:prstGeom>
-        </p:spPr>
-        <p:style>
-          <a:lnRef idx="2">
-            <a:schemeClr val="dk1"/>
-          </a:lnRef>
-          <a:fillRef idx="0">
-            <a:schemeClr val="dk1"/>
-          </a:fillRef>
-          <a:effectRef idx="1">
-            <a:schemeClr val="dk1"/>
-          </a:effectRef>
-          <a:fontRef idx="minor">
-            <a:schemeClr val="tx1"/>
-          </a:fontRef>
-        </p:style>
-      </p:cxnSp>
-      <p:sp>
-        <p:nvSpPr>
-          <p:cNvPr id="9" name="TextBox 8">
-            <a:extLst>
-              <a:ext uri="{FF2B5EF4-FFF2-40B4-BE49-F238E27FC236}">
-                <a16:creationId xmlns:a16="http://schemas.microsoft.com/office/drawing/2014/main" id="{305363A5-FAF7-3FE3-B3FC-191E041CB1DC}"/>
-              </a:ext>
-            </a:extLst>
-          </p:cNvPr>
-          <p:cNvSpPr txBox="1"/>
-          <p:nvPr/>
-        </p:nvSpPr>
-        <p:spPr>
-          <a:xfrm>
-            <a:off x="723687" y="4445000"/>
-            <a:ext cx="1232325" cy="646331"/>
-          </a:xfrm>
-          <a:prstGeom prst="rect">
-            <a:avLst/>
-          </a:prstGeom>
-          <a:noFill/>
-        </p:spPr>
-        <p:txBody>
-          <a:bodyPr wrap="none" rtlCol="0">
-            <a:spAutoFit/>
-          </a:bodyPr>
-          <a:lstStyle/>
-          <a:p>
-            <a:pPr algn="ctr"/>
-            <a:r>
-              <a:rPr lang="en-US" b="1"/>
-              <a:t>1950</a:t>
-            </a:r>
-          </a:p>
-          <a:p>
-            <a:pPr algn="ctr"/>
-            <a:r>
-              <a:rPr lang="en-US"/>
-              <a:t>Turing Test</a:t>
-            </a:r>
-          </a:p>
-        </p:txBody>
-      </p:sp>
-      <p:sp>
-        <p:nvSpPr>
-          <p:cNvPr id="10" name="Oval 9">
-            <a:extLst>
-              <a:ext uri="{FF2B5EF4-FFF2-40B4-BE49-F238E27FC236}">
-                <a16:creationId xmlns:a16="http://schemas.microsoft.com/office/drawing/2014/main" id="{BBFE5CDE-9343-52BE-D424-8C1279266566}"/>
-              </a:ext>
-            </a:extLst>
-          </p:cNvPr>
-          <p:cNvSpPr/>
-          <p:nvPr/>
-        </p:nvSpPr>
-        <p:spPr>
-          <a:xfrm>
-            <a:off x="2428371" y="3270045"/>
-            <a:ext cx="309716" cy="309716"/>
-          </a:xfrm>
-          <a:prstGeom prst="ellipse">
-            <a:avLst/>
-          </a:prstGeom>
-        </p:spPr>
-        <p:style>
-          <a:lnRef idx="2">
-            <a:schemeClr val="dk1">
-              <a:shade val="15000"/>
-            </a:schemeClr>
-          </a:lnRef>
-          <a:fillRef idx="1">
-            <a:schemeClr val="dk1"/>
-          </a:fillRef>
-          <a:effectRef idx="0">
-            <a:schemeClr val="dk1"/>
-          </a:effectRef>
-          <a:fontRef idx="minor">
-            <a:schemeClr val="lt1"/>
-          </a:fontRef>
-        </p:style>
-        <p:txBody>
-          <a:bodyPr rtlCol="0" anchor="ctr"/>
-          <a:lstStyle/>
-          <a:p>
-            <a:pPr algn="ctr"/>
-            <a:endParaRPr lang="en-US"/>
-          </a:p>
-        </p:txBody>
-      </p:sp>
-      <p:cxnSp>
-        <p:nvCxnSpPr>
-          <p:cNvPr id="13" name="Straight Connector 12">
-            <a:extLst>
-              <a:ext uri="{FF2B5EF4-FFF2-40B4-BE49-F238E27FC236}">
-                <a16:creationId xmlns:a16="http://schemas.microsoft.com/office/drawing/2014/main" id="{B79FF55B-AA15-DDF8-CCE0-5ACFAAA908C5}"/>
-              </a:ext>
-            </a:extLst>
-          </p:cNvPr>
-          <p:cNvCxnSpPr>
-            <a:cxnSpLocks/>
-          </p:cNvCxnSpPr>
-          <p:nvPr/>
-        </p:nvCxnSpPr>
-        <p:spPr>
-          <a:xfrm>
-            <a:off x="2583229" y="2359742"/>
-            <a:ext cx="0" cy="914400"/>
-          </a:xfrm>
-          <a:prstGeom prst="line">
-            <a:avLst/>
-          </a:prstGeom>
-        </p:spPr>
-        <p:style>
-          <a:lnRef idx="2">
-            <a:schemeClr val="dk1"/>
-          </a:lnRef>
-          <a:fillRef idx="0">
-            <a:schemeClr val="dk1"/>
-          </a:fillRef>
-          <a:effectRef idx="1">
-            <a:schemeClr val="dk1"/>
-          </a:effectRef>
-          <a:fontRef idx="minor">
-            <a:schemeClr val="tx1"/>
-          </a:fontRef>
-        </p:style>
-      </p:cxnSp>
-      <p:sp>
-        <p:nvSpPr>
-          <p:cNvPr id="28" name="Oval 27">
-            <a:extLst>
-              <a:ext uri="{FF2B5EF4-FFF2-40B4-BE49-F238E27FC236}">
-                <a16:creationId xmlns:a16="http://schemas.microsoft.com/office/drawing/2014/main" id="{5D2D362F-FB80-B527-3FE3-4198CEA5A225}"/>
-              </a:ext>
-            </a:extLst>
-          </p:cNvPr>
-          <p:cNvSpPr/>
-          <p:nvPr/>
-        </p:nvSpPr>
-        <p:spPr>
-          <a:xfrm>
-            <a:off x="3575576" y="3270045"/>
-            <a:ext cx="309716" cy="309716"/>
-          </a:xfrm>
-          <a:prstGeom prst="ellipse">
-            <a:avLst/>
-          </a:prstGeom>
-        </p:spPr>
-        <p:style>
-          <a:lnRef idx="2">
-            <a:schemeClr val="dk1">
-              <a:shade val="15000"/>
-            </a:schemeClr>
-          </a:lnRef>
-          <a:fillRef idx="1">
-            <a:schemeClr val="dk1"/>
-          </a:fillRef>
-          <a:effectRef idx="0">
-            <a:schemeClr val="dk1"/>
-          </a:effectRef>
-          <a:fontRef idx="minor">
-            <a:schemeClr val="lt1"/>
-          </a:fontRef>
-        </p:style>
-        <p:txBody>
-          <a:bodyPr rtlCol="0" anchor="ctr"/>
-          <a:lstStyle/>
-          <a:p>
-            <a:pPr algn="ctr"/>
-            <a:endParaRPr lang="en-US"/>
-          </a:p>
-        </p:txBody>
-      </p:sp>
-      <p:cxnSp>
-        <p:nvCxnSpPr>
-          <p:cNvPr id="29" name="Straight Connector 28">
-            <a:extLst>
-              <a:ext uri="{FF2B5EF4-FFF2-40B4-BE49-F238E27FC236}">
-                <a16:creationId xmlns:a16="http://schemas.microsoft.com/office/drawing/2014/main" id="{3E1A0A8A-5CB6-A6E1-D4C7-C5E5952AA478}"/>
-              </a:ext>
-            </a:extLst>
-          </p:cNvPr>
-          <p:cNvCxnSpPr>
-            <a:cxnSpLocks/>
-            <a:stCxn id="28" idx="4"/>
-          </p:cNvCxnSpPr>
-          <p:nvPr/>
-        </p:nvCxnSpPr>
-        <p:spPr>
-          <a:xfrm flipH="1">
-            <a:off x="3725255" y="3579761"/>
-            <a:ext cx="5179" cy="861142"/>
-          </a:xfrm>
-          <a:prstGeom prst="line">
-            <a:avLst/>
-          </a:prstGeom>
-        </p:spPr>
-        <p:style>
-          <a:lnRef idx="2">
-            <a:schemeClr val="dk1"/>
-          </a:lnRef>
-          <a:fillRef idx="0">
-            <a:schemeClr val="dk1"/>
-          </a:fillRef>
-          <a:effectRef idx="1">
-            <a:schemeClr val="dk1"/>
-          </a:effectRef>
-          <a:fontRef idx="minor">
-            <a:schemeClr val="tx1"/>
-          </a:fontRef>
-        </p:style>
-      </p:cxnSp>
-      <p:sp>
-        <p:nvSpPr>
-          <p:cNvPr id="30" name="Oval 29">
-            <a:extLst>
-              <a:ext uri="{FF2B5EF4-FFF2-40B4-BE49-F238E27FC236}">
-                <a16:creationId xmlns:a16="http://schemas.microsoft.com/office/drawing/2014/main" id="{7524CCD3-960C-76C1-3CDA-4615BD8DCCCE}"/>
-              </a:ext>
-            </a:extLst>
-          </p:cNvPr>
-          <p:cNvSpPr/>
-          <p:nvPr/>
-        </p:nvSpPr>
-        <p:spPr>
-          <a:xfrm>
-            <a:off x="4727960" y="3270045"/>
-            <a:ext cx="309716" cy="309716"/>
-          </a:xfrm>
-          <a:prstGeom prst="ellipse">
-            <a:avLst/>
-          </a:prstGeom>
-        </p:spPr>
-        <p:style>
-          <a:lnRef idx="2">
-            <a:schemeClr val="dk1">
-              <a:shade val="15000"/>
-            </a:schemeClr>
-          </a:lnRef>
-          <a:fillRef idx="1">
-            <a:schemeClr val="dk1"/>
-          </a:fillRef>
-          <a:effectRef idx="0">
-            <a:schemeClr val="dk1"/>
-          </a:effectRef>
-          <a:fontRef idx="minor">
-            <a:schemeClr val="lt1"/>
-          </a:fontRef>
-        </p:style>
-        <p:txBody>
-          <a:bodyPr rtlCol="0" anchor="ctr"/>
-          <a:lstStyle/>
-          <a:p>
-            <a:pPr algn="ctr"/>
-            <a:endParaRPr lang="en-US"/>
-          </a:p>
-        </p:txBody>
-      </p:sp>
-      <p:cxnSp>
-        <p:nvCxnSpPr>
-          <p:cNvPr id="31" name="Straight Connector 30">
-            <a:extLst>
-              <a:ext uri="{FF2B5EF4-FFF2-40B4-BE49-F238E27FC236}">
-                <a16:creationId xmlns:a16="http://schemas.microsoft.com/office/drawing/2014/main" id="{CE31BDC7-F229-9D78-58AB-F50D95100BED}"/>
-              </a:ext>
-            </a:extLst>
-          </p:cNvPr>
-          <p:cNvCxnSpPr>
-            <a:cxnSpLocks/>
-          </p:cNvCxnSpPr>
-          <p:nvPr/>
-        </p:nvCxnSpPr>
-        <p:spPr>
-          <a:xfrm flipH="1">
-            <a:off x="4882819" y="2353597"/>
-            <a:ext cx="5179" cy="914400"/>
-          </a:xfrm>
-          <a:prstGeom prst="line">
-            <a:avLst/>
-          </a:prstGeom>
-        </p:spPr>
-        <p:style>
-          <a:lnRef idx="2">
-            <a:schemeClr val="dk1"/>
-          </a:lnRef>
-          <a:fillRef idx="0">
-            <a:schemeClr val="dk1"/>
-          </a:fillRef>
-          <a:effectRef idx="1">
-            <a:schemeClr val="dk1"/>
-          </a:effectRef>
-          <a:fontRef idx="minor">
-            <a:schemeClr val="tx1"/>
-          </a:fontRef>
-        </p:style>
-      </p:cxnSp>
-      <p:sp>
-        <p:nvSpPr>
-          <p:cNvPr id="32" name="Oval 31">
-            <a:extLst>
-              <a:ext uri="{FF2B5EF4-FFF2-40B4-BE49-F238E27FC236}">
-                <a16:creationId xmlns:a16="http://schemas.microsoft.com/office/drawing/2014/main" id="{4CB1A46B-81F4-273A-2223-EC5BB878D149}"/>
-              </a:ext>
-            </a:extLst>
-          </p:cNvPr>
-          <p:cNvSpPr/>
-          <p:nvPr/>
-        </p:nvSpPr>
-        <p:spPr>
-          <a:xfrm>
-            <a:off x="5875165" y="3270045"/>
-            <a:ext cx="309716" cy="309716"/>
-          </a:xfrm>
-          <a:prstGeom prst="ellipse">
-            <a:avLst/>
-          </a:prstGeom>
-        </p:spPr>
-        <p:style>
-          <a:lnRef idx="2">
-            <a:schemeClr val="dk1">
-              <a:shade val="15000"/>
-            </a:schemeClr>
-          </a:lnRef>
-          <a:fillRef idx="1">
-            <a:schemeClr val="dk1"/>
-          </a:fillRef>
-          <a:effectRef idx="0">
-            <a:schemeClr val="dk1"/>
-          </a:effectRef>
-          <a:fontRef idx="minor">
-            <a:schemeClr val="lt1"/>
-          </a:fontRef>
-        </p:style>
-        <p:txBody>
-          <a:bodyPr rtlCol="0" anchor="ctr"/>
-          <a:lstStyle/>
-          <a:p>
-            <a:pPr algn="ctr"/>
-            <a:endParaRPr lang="en-US"/>
-          </a:p>
-        </p:txBody>
-      </p:sp>
-      <p:cxnSp>
-        <p:nvCxnSpPr>
-          <p:cNvPr id="33" name="Straight Connector 32">
-            <a:extLst>
-              <a:ext uri="{FF2B5EF4-FFF2-40B4-BE49-F238E27FC236}">
-                <a16:creationId xmlns:a16="http://schemas.microsoft.com/office/drawing/2014/main" id="{98477674-BE41-4CAB-0E97-8E4A09BF8CEA}"/>
-              </a:ext>
-            </a:extLst>
-          </p:cNvPr>
-          <p:cNvCxnSpPr>
-            <a:cxnSpLocks/>
-            <a:stCxn id="32" idx="4"/>
-          </p:cNvCxnSpPr>
-          <p:nvPr/>
-        </p:nvCxnSpPr>
-        <p:spPr>
-          <a:xfrm flipH="1">
-            <a:off x="6024844" y="3579761"/>
-            <a:ext cx="5179" cy="861142"/>
-          </a:xfrm>
-          <a:prstGeom prst="line">
-            <a:avLst/>
-          </a:prstGeom>
-        </p:spPr>
-        <p:style>
-          <a:lnRef idx="2">
-            <a:schemeClr val="dk1"/>
-          </a:lnRef>
-          <a:fillRef idx="0">
-            <a:schemeClr val="dk1"/>
-          </a:fillRef>
-          <a:effectRef idx="1">
-            <a:schemeClr val="dk1"/>
-          </a:effectRef>
-          <a:fontRef idx="minor">
-            <a:schemeClr val="tx1"/>
-          </a:fontRef>
-        </p:style>
-      </p:cxnSp>
-      <p:sp>
-        <p:nvSpPr>
-          <p:cNvPr id="34" name="Oval 33">
-            <a:extLst>
-              <a:ext uri="{FF2B5EF4-FFF2-40B4-BE49-F238E27FC236}">
-                <a16:creationId xmlns:a16="http://schemas.microsoft.com/office/drawing/2014/main" id="{EA85BE0C-961E-EA3B-37AE-A47090A97B55}"/>
-              </a:ext>
-            </a:extLst>
-          </p:cNvPr>
-          <p:cNvSpPr/>
-          <p:nvPr/>
-        </p:nvSpPr>
-        <p:spPr>
-          <a:xfrm>
-            <a:off x="7027549" y="3270045"/>
-            <a:ext cx="309716" cy="309716"/>
-          </a:xfrm>
-          <a:prstGeom prst="ellipse">
-            <a:avLst/>
-          </a:prstGeom>
-        </p:spPr>
-        <p:style>
-          <a:lnRef idx="2">
-            <a:schemeClr val="dk1">
-              <a:shade val="15000"/>
-            </a:schemeClr>
-          </a:lnRef>
-          <a:fillRef idx="1">
-            <a:schemeClr val="dk1"/>
-          </a:fillRef>
-          <a:effectRef idx="0">
-            <a:schemeClr val="dk1"/>
-          </a:effectRef>
-          <a:fontRef idx="minor">
-            <a:schemeClr val="lt1"/>
-          </a:fontRef>
-        </p:style>
-        <p:txBody>
-          <a:bodyPr rtlCol="0" anchor="ctr"/>
-          <a:lstStyle/>
-          <a:p>
-            <a:pPr algn="ctr"/>
-            <a:endParaRPr lang="en-US"/>
-          </a:p>
-        </p:txBody>
-      </p:sp>
-      <p:cxnSp>
-        <p:nvCxnSpPr>
-          <p:cNvPr id="35" name="Straight Connector 34">
-            <a:extLst>
-              <a:ext uri="{FF2B5EF4-FFF2-40B4-BE49-F238E27FC236}">
-                <a16:creationId xmlns:a16="http://schemas.microsoft.com/office/drawing/2014/main" id="{07D26A5C-221C-5952-A7CC-DAF0CC1F5314}"/>
-              </a:ext>
-            </a:extLst>
-          </p:cNvPr>
-          <p:cNvCxnSpPr>
-            <a:cxnSpLocks/>
-          </p:cNvCxnSpPr>
-          <p:nvPr/>
-        </p:nvCxnSpPr>
-        <p:spPr>
-          <a:xfrm>
-            <a:off x="7182407" y="2351548"/>
-            <a:ext cx="0" cy="914400"/>
-          </a:xfrm>
-          <a:prstGeom prst="line">
-            <a:avLst/>
-          </a:prstGeom>
-        </p:spPr>
-        <p:style>
-          <a:lnRef idx="2">
-            <a:schemeClr val="dk1"/>
-          </a:lnRef>
-          <a:fillRef idx="0">
-            <a:schemeClr val="dk1"/>
-          </a:fillRef>
-          <a:effectRef idx="1">
-            <a:schemeClr val="dk1"/>
-          </a:effectRef>
-          <a:fontRef idx="minor">
-            <a:schemeClr val="tx1"/>
-          </a:fontRef>
-        </p:style>
-      </p:cxnSp>
-      <p:sp>
-        <p:nvSpPr>
-          <p:cNvPr id="36" name="Oval 35">
-            <a:extLst>
-              <a:ext uri="{FF2B5EF4-FFF2-40B4-BE49-F238E27FC236}">
-                <a16:creationId xmlns:a16="http://schemas.microsoft.com/office/drawing/2014/main" id="{331FBDF8-BF17-2FF1-E2DB-C246080EC5D0}"/>
-              </a:ext>
-            </a:extLst>
-          </p:cNvPr>
-          <p:cNvSpPr/>
-          <p:nvPr/>
-        </p:nvSpPr>
-        <p:spPr>
-          <a:xfrm>
-            <a:off x="8174754" y="3270045"/>
-            <a:ext cx="309716" cy="309716"/>
-          </a:xfrm>
-          <a:prstGeom prst="ellipse">
-            <a:avLst/>
-          </a:prstGeom>
-        </p:spPr>
-        <p:style>
-          <a:lnRef idx="2">
-            <a:schemeClr val="dk1">
-              <a:shade val="15000"/>
-            </a:schemeClr>
-          </a:lnRef>
-          <a:fillRef idx="1">
-            <a:schemeClr val="dk1"/>
-          </a:fillRef>
-          <a:effectRef idx="0">
-            <a:schemeClr val="dk1"/>
-          </a:effectRef>
-          <a:fontRef idx="minor">
-            <a:schemeClr val="lt1"/>
-          </a:fontRef>
-        </p:style>
-        <p:txBody>
-          <a:bodyPr rtlCol="0" anchor="ctr"/>
-          <a:lstStyle/>
-          <a:p>
-            <a:pPr algn="ctr"/>
-            <a:endParaRPr lang="en-US"/>
-          </a:p>
-        </p:txBody>
-      </p:sp>
-      <p:cxnSp>
-        <p:nvCxnSpPr>
-          <p:cNvPr id="37" name="Straight Connector 36">
-            <a:extLst>
-              <a:ext uri="{FF2B5EF4-FFF2-40B4-BE49-F238E27FC236}">
-                <a16:creationId xmlns:a16="http://schemas.microsoft.com/office/drawing/2014/main" id="{7D86C0EB-7756-32AD-5C1D-20EBDBF64562}"/>
-              </a:ext>
-            </a:extLst>
-          </p:cNvPr>
-          <p:cNvCxnSpPr>
-            <a:cxnSpLocks/>
-            <a:stCxn id="36" idx="4"/>
-          </p:cNvCxnSpPr>
-          <p:nvPr/>
-        </p:nvCxnSpPr>
-        <p:spPr>
-          <a:xfrm flipH="1">
-            <a:off x="8324433" y="3579761"/>
-            <a:ext cx="5179" cy="861142"/>
-          </a:xfrm>
-          <a:prstGeom prst="line">
-            <a:avLst/>
-          </a:prstGeom>
-        </p:spPr>
-        <p:style>
-          <a:lnRef idx="2">
-            <a:schemeClr val="dk1"/>
-          </a:lnRef>
-          <a:fillRef idx="0">
-            <a:schemeClr val="dk1"/>
-          </a:fillRef>
-          <a:effectRef idx="1">
-            <a:schemeClr val="dk1"/>
-          </a:effectRef>
-          <a:fontRef idx="minor">
-            <a:schemeClr val="tx1"/>
-          </a:fontRef>
-        </p:style>
-      </p:cxnSp>
-      <p:sp>
-        <p:nvSpPr>
-          <p:cNvPr id="38" name="Oval 37">
-            <a:extLst>
-              <a:ext uri="{FF2B5EF4-FFF2-40B4-BE49-F238E27FC236}">
-                <a16:creationId xmlns:a16="http://schemas.microsoft.com/office/drawing/2014/main" id="{104435A5-BDA0-9A4D-1E9E-A33E12FA5ED6}"/>
-              </a:ext>
-            </a:extLst>
-          </p:cNvPr>
-          <p:cNvSpPr/>
-          <p:nvPr/>
-        </p:nvSpPr>
-        <p:spPr>
-          <a:xfrm>
-            <a:off x="9327138" y="3270045"/>
-            <a:ext cx="309716" cy="309716"/>
-          </a:xfrm>
-          <a:prstGeom prst="ellipse">
-            <a:avLst/>
-          </a:prstGeom>
-        </p:spPr>
-        <p:style>
-          <a:lnRef idx="2">
-            <a:schemeClr val="dk1">
-              <a:shade val="15000"/>
-            </a:schemeClr>
-          </a:lnRef>
-          <a:fillRef idx="1">
-            <a:schemeClr val="dk1"/>
-          </a:fillRef>
-          <a:effectRef idx="0">
-            <a:schemeClr val="dk1"/>
-          </a:effectRef>
-          <a:fontRef idx="minor">
-            <a:schemeClr val="lt1"/>
-          </a:fontRef>
-        </p:style>
-        <p:txBody>
-          <a:bodyPr rtlCol="0" anchor="ctr"/>
-          <a:lstStyle/>
-          <a:p>
-            <a:pPr algn="ctr"/>
-            <a:endParaRPr lang="en-US"/>
-          </a:p>
-        </p:txBody>
-      </p:sp>
-      <p:cxnSp>
-        <p:nvCxnSpPr>
-          <p:cNvPr id="39" name="Straight Connector 38">
-            <a:extLst>
-              <a:ext uri="{FF2B5EF4-FFF2-40B4-BE49-F238E27FC236}">
-                <a16:creationId xmlns:a16="http://schemas.microsoft.com/office/drawing/2014/main" id="{34211C5F-D4E1-BFA8-ED38-8CBE6370B4FD}"/>
-              </a:ext>
-            </a:extLst>
-          </p:cNvPr>
-          <p:cNvCxnSpPr>
-            <a:cxnSpLocks/>
-          </p:cNvCxnSpPr>
-          <p:nvPr/>
-        </p:nvCxnSpPr>
-        <p:spPr>
-          <a:xfrm flipH="1">
-            <a:off x="9481996" y="2351548"/>
-            <a:ext cx="0" cy="914400"/>
-          </a:xfrm>
-          <a:prstGeom prst="line">
-            <a:avLst/>
-          </a:prstGeom>
-        </p:spPr>
-        <p:style>
-          <a:lnRef idx="2">
-            <a:schemeClr val="dk1"/>
-          </a:lnRef>
-          <a:fillRef idx="0">
-            <a:schemeClr val="dk1"/>
-          </a:fillRef>
-          <a:effectRef idx="1">
-            <a:schemeClr val="dk1"/>
-          </a:effectRef>
-          <a:fontRef idx="minor">
-            <a:schemeClr val="tx1"/>
-          </a:fontRef>
-        </p:style>
-      </p:cxnSp>
-      <p:sp>
-        <p:nvSpPr>
-          <p:cNvPr id="48" name="TextBox 47">
-            <a:extLst>
-              <a:ext uri="{FF2B5EF4-FFF2-40B4-BE49-F238E27FC236}">
-                <a16:creationId xmlns:a16="http://schemas.microsoft.com/office/drawing/2014/main" id="{F6CDB75E-4479-1C83-7C10-731CF8ECF3B0}"/>
-              </a:ext>
-            </a:extLst>
-          </p:cNvPr>
-          <p:cNvSpPr txBox="1"/>
-          <p:nvPr/>
-        </p:nvSpPr>
-        <p:spPr>
-          <a:xfrm>
-            <a:off x="1812024" y="1151219"/>
-            <a:ext cx="1542409" cy="1200329"/>
-          </a:xfrm>
-          <a:prstGeom prst="rect">
-            <a:avLst/>
-          </a:prstGeom>
-          <a:noFill/>
-        </p:spPr>
-        <p:txBody>
-          <a:bodyPr wrap="none" rtlCol="0">
-            <a:spAutoFit/>
-          </a:bodyPr>
-          <a:lstStyle/>
-          <a:p>
-            <a:pPr algn="ctr"/>
-            <a:r>
-              <a:rPr lang="en-US" b="1"/>
-              <a:t>1954</a:t>
-            </a:r>
-          </a:p>
-          <a:p>
-            <a:pPr algn="ctr"/>
-            <a:r>
-              <a:rPr lang="en-US"/>
-              <a:t>Hệ thống NLP</a:t>
-            </a:r>
-          </a:p>
-          <a:p>
-            <a:pPr algn="ctr"/>
-            <a:r>
-              <a:rPr lang="en-US"/>
-              <a:t>sử dụng AI</a:t>
-            </a:r>
-          </a:p>
-          <a:p>
-            <a:pPr algn="ctr"/>
-            <a:r>
-              <a:rPr lang="en-US"/>
-              <a:t>đầu tiên</a:t>
-            </a:r>
-          </a:p>
-        </p:txBody>
-      </p:sp>
-      <p:sp>
-        <p:nvSpPr>
-          <p:cNvPr id="49" name="TextBox 48">
-            <a:extLst>
-              <a:ext uri="{FF2B5EF4-FFF2-40B4-BE49-F238E27FC236}">
-                <a16:creationId xmlns:a16="http://schemas.microsoft.com/office/drawing/2014/main" id="{C42AA5A2-807B-7A5F-4975-F3D1D774F07F}"/>
-              </a:ext>
-            </a:extLst>
-          </p:cNvPr>
-          <p:cNvSpPr txBox="1"/>
-          <p:nvPr/>
-        </p:nvSpPr>
-        <p:spPr>
-          <a:xfrm>
-            <a:off x="2842828" y="4440903"/>
-            <a:ext cx="1770035" cy="923330"/>
-          </a:xfrm>
-          <a:prstGeom prst="rect">
-            <a:avLst/>
-          </a:prstGeom>
-          <a:noFill/>
-        </p:spPr>
-        <p:txBody>
-          <a:bodyPr wrap="none" rtlCol="0">
-            <a:spAutoFit/>
-          </a:bodyPr>
-          <a:lstStyle/>
-          <a:p>
-            <a:pPr algn="ctr"/>
-            <a:r>
-              <a:rPr lang="en-US" b="1"/>
-              <a:t>1990</a:t>
-            </a:r>
-          </a:p>
-          <a:p>
-            <a:pPr algn="ctr"/>
-            <a:r>
-              <a:rPr lang="en-US"/>
-              <a:t>Sự khởi đầu của</a:t>
-            </a:r>
-          </a:p>
-          <a:p>
-            <a:pPr algn="ctr"/>
-            <a:r>
-              <a:rPr lang="en-US"/>
-              <a:t>NLP với ML</a:t>
-            </a:r>
-          </a:p>
-        </p:txBody>
-      </p:sp>
-      <p:sp>
-        <p:nvSpPr>
-          <p:cNvPr id="50" name="TextBox 49">
-            <a:extLst>
-              <a:ext uri="{FF2B5EF4-FFF2-40B4-BE49-F238E27FC236}">
-                <a16:creationId xmlns:a16="http://schemas.microsoft.com/office/drawing/2014/main" id="{55D0DC0D-61E9-0C5B-6C24-32B161B0597B}"/>
-              </a:ext>
-            </a:extLst>
-          </p:cNvPr>
-          <p:cNvSpPr txBox="1"/>
-          <p:nvPr/>
-        </p:nvSpPr>
-        <p:spPr>
-          <a:xfrm>
-            <a:off x="4258512" y="1696845"/>
-            <a:ext cx="1248612" cy="646331"/>
-          </a:xfrm>
-          <a:prstGeom prst="rect">
-            <a:avLst/>
-          </a:prstGeom>
-          <a:noFill/>
-        </p:spPr>
-        <p:txBody>
-          <a:bodyPr wrap="none" rtlCol="0">
-            <a:spAutoFit/>
-          </a:bodyPr>
-          <a:lstStyle/>
-          <a:p>
-            <a:pPr algn="ctr"/>
-            <a:r>
-              <a:rPr lang="en-US" b="1"/>
-              <a:t>1990s</a:t>
-            </a:r>
-          </a:p>
-          <a:p>
-            <a:pPr algn="ctr"/>
-            <a:r>
-              <a:rPr lang="en-US"/>
-              <a:t>ANN ra đời</a:t>
-            </a:r>
-          </a:p>
-        </p:txBody>
-      </p:sp>
-      <p:sp>
-        <p:nvSpPr>
-          <p:cNvPr id="51" name="TextBox 50">
-            <a:extLst>
-              <a:ext uri="{FF2B5EF4-FFF2-40B4-BE49-F238E27FC236}">
-                <a16:creationId xmlns:a16="http://schemas.microsoft.com/office/drawing/2014/main" id="{C3F0034D-3EEB-1282-EC4E-BBE91016FEC0}"/>
-              </a:ext>
-            </a:extLst>
-          </p:cNvPr>
-          <p:cNvSpPr txBox="1"/>
-          <p:nvPr/>
-        </p:nvSpPr>
-        <p:spPr>
-          <a:xfrm>
-            <a:off x="4941055" y="4440903"/>
-            <a:ext cx="2167581" cy="646331"/>
-          </a:xfrm>
-          <a:prstGeom prst="rect">
-            <a:avLst/>
-          </a:prstGeom>
-          <a:noFill/>
-        </p:spPr>
-        <p:txBody>
-          <a:bodyPr wrap="none" rtlCol="0">
-            <a:spAutoFit/>
-          </a:bodyPr>
-          <a:lstStyle/>
-          <a:p>
-            <a:pPr algn="ctr"/>
-            <a:r>
-              <a:rPr lang="en-US" b="1"/>
-              <a:t>1990s</a:t>
-            </a:r>
-          </a:p>
-          <a:p>
-            <a:pPr algn="ctr"/>
-            <a:r>
-              <a:rPr lang="en-US"/>
-              <a:t>RNN được giới thiệu</a:t>
-            </a:r>
-          </a:p>
-        </p:txBody>
-      </p:sp>
-      <p:sp>
-        <p:nvSpPr>
-          <p:cNvPr id="52" name="TextBox 51">
-            <a:extLst>
-              <a:ext uri="{FF2B5EF4-FFF2-40B4-BE49-F238E27FC236}">
-                <a16:creationId xmlns:a16="http://schemas.microsoft.com/office/drawing/2014/main" id="{21A896BF-99A1-C230-0A35-B24A78C51167}"/>
-              </a:ext>
-            </a:extLst>
-          </p:cNvPr>
-          <p:cNvSpPr txBox="1"/>
-          <p:nvPr/>
-        </p:nvSpPr>
-        <p:spPr>
-          <a:xfrm>
-            <a:off x="7579139" y="4440903"/>
-            <a:ext cx="1500732" cy="923330"/>
-          </a:xfrm>
-          <a:prstGeom prst="rect">
-            <a:avLst/>
-          </a:prstGeom>
-          <a:noFill/>
-        </p:spPr>
-        <p:txBody>
-          <a:bodyPr wrap="none" rtlCol="0">
-            <a:spAutoFit/>
-          </a:bodyPr>
-          <a:lstStyle/>
-          <a:p>
-            <a:pPr algn="ctr"/>
-            <a:r>
-              <a:rPr lang="en-US" b="1">
-                <a:solidFill>
-                  <a:srgbClr val="FF0000"/>
-                </a:solidFill>
-              </a:rPr>
-              <a:t>2013</a:t>
-            </a:r>
-          </a:p>
-          <a:p>
-            <a:pPr algn="ctr"/>
-            <a:r>
-              <a:rPr lang="en-US">
-                <a:solidFill>
-                  <a:srgbClr val="FF0000"/>
-                </a:solidFill>
-              </a:rPr>
-              <a:t>Bước tiến lớn</a:t>
-            </a:r>
-          </a:p>
-          <a:p>
-            <a:pPr algn="ctr"/>
-            <a:r>
-              <a:rPr lang="en-US">
-                <a:solidFill>
-                  <a:srgbClr val="FF0000"/>
-                </a:solidFill>
-              </a:rPr>
-              <a:t>với DL</a:t>
-            </a:r>
-          </a:p>
-        </p:txBody>
-      </p:sp>
-      <p:sp>
-        <p:nvSpPr>
-          <p:cNvPr id="53" name="TextBox 52">
-            <a:extLst>
-              <a:ext uri="{FF2B5EF4-FFF2-40B4-BE49-F238E27FC236}">
-                <a16:creationId xmlns:a16="http://schemas.microsoft.com/office/drawing/2014/main" id="{8FD8DEF4-C432-0133-FD3E-1E210A590AC8}"/>
-              </a:ext>
-            </a:extLst>
-          </p:cNvPr>
-          <p:cNvSpPr txBox="1"/>
-          <p:nvPr/>
-        </p:nvSpPr>
-        <p:spPr>
-          <a:xfrm>
-            <a:off x="6347563" y="1696846"/>
-            <a:ext cx="1669688" cy="646331"/>
-          </a:xfrm>
-          <a:prstGeom prst="rect">
-            <a:avLst/>
-          </a:prstGeom>
-          <a:noFill/>
-        </p:spPr>
-        <p:txBody>
-          <a:bodyPr wrap="none" rtlCol="0">
-            <a:spAutoFit/>
-          </a:bodyPr>
-          <a:lstStyle/>
-          <a:p>
-            <a:pPr algn="ctr"/>
-            <a:r>
-              <a:rPr lang="en-US" b="1"/>
-              <a:t>1997</a:t>
-            </a:r>
-          </a:p>
-          <a:p>
-            <a:pPr algn="ctr"/>
-            <a:r>
-              <a:rPr lang="en-US"/>
-              <a:t>LSTM xuất hiện</a:t>
-            </a:r>
-          </a:p>
-        </p:txBody>
-      </p:sp>
-      <p:sp>
-        <p:nvSpPr>
-          <p:cNvPr id="54" name="TextBox 53">
-            <a:extLst>
-              <a:ext uri="{FF2B5EF4-FFF2-40B4-BE49-F238E27FC236}">
-                <a16:creationId xmlns:a16="http://schemas.microsoft.com/office/drawing/2014/main" id="{961525B6-43AB-2488-D415-7DBCC162E2B5}"/>
-              </a:ext>
-            </a:extLst>
-          </p:cNvPr>
-          <p:cNvSpPr txBox="1"/>
-          <p:nvPr/>
-        </p:nvSpPr>
-        <p:spPr>
-          <a:xfrm>
-            <a:off x="8767377" y="1696844"/>
-            <a:ext cx="1429238" cy="646331"/>
-          </a:xfrm>
-          <a:prstGeom prst="rect">
-            <a:avLst/>
-          </a:prstGeom>
-          <a:noFill/>
-        </p:spPr>
-        <p:txBody>
-          <a:bodyPr wrap="none" rtlCol="0">
-            <a:spAutoFit/>
-          </a:bodyPr>
-          <a:lstStyle/>
-          <a:p>
-            <a:pPr algn="ctr"/>
-            <a:r>
-              <a:rPr lang="en-US" b="1"/>
-              <a:t>2017</a:t>
-            </a:r>
-          </a:p>
-          <a:p>
-            <a:pPr algn="ctr"/>
-            <a:r>
-              <a:rPr lang="en-US"/>
-              <a:t>Transformer</a:t>
-            </a:r>
-          </a:p>
-        </p:txBody>
-      </p:sp>
-      <p:sp>
-        <p:nvSpPr>
-          <p:cNvPr id="55" name="Oval 54">
-            <a:extLst>
-              <a:ext uri="{FF2B5EF4-FFF2-40B4-BE49-F238E27FC236}">
-                <a16:creationId xmlns:a16="http://schemas.microsoft.com/office/drawing/2014/main" id="{3B8F907F-9F48-7850-75D9-9E3E25598592}"/>
-              </a:ext>
-            </a:extLst>
-          </p:cNvPr>
-          <p:cNvSpPr/>
-          <p:nvPr/>
-        </p:nvSpPr>
-        <p:spPr>
-          <a:xfrm>
-            <a:off x="10563196" y="3270045"/>
-            <a:ext cx="309716" cy="309716"/>
-          </a:xfrm>
-          <a:prstGeom prst="ellipse">
-            <a:avLst/>
-          </a:prstGeom>
-        </p:spPr>
-        <p:style>
-          <a:lnRef idx="2">
-            <a:schemeClr val="dk1">
-              <a:shade val="15000"/>
-            </a:schemeClr>
-          </a:lnRef>
-          <a:fillRef idx="1">
-            <a:schemeClr val="dk1"/>
-          </a:fillRef>
-          <a:effectRef idx="0">
-            <a:schemeClr val="dk1"/>
-          </a:effectRef>
-          <a:fontRef idx="minor">
-            <a:schemeClr val="lt1"/>
-          </a:fontRef>
-        </p:style>
-        <p:txBody>
-          <a:bodyPr rtlCol="0" anchor="ctr"/>
-          <a:lstStyle/>
-          <a:p>
-            <a:pPr algn="ctr"/>
-            <a:endParaRPr lang="en-US"/>
-          </a:p>
-        </p:txBody>
-      </p:sp>
-      <p:cxnSp>
-        <p:nvCxnSpPr>
-          <p:cNvPr id="56" name="Straight Connector 55">
-            <a:extLst>
-              <a:ext uri="{FF2B5EF4-FFF2-40B4-BE49-F238E27FC236}">
-                <a16:creationId xmlns:a16="http://schemas.microsoft.com/office/drawing/2014/main" id="{0241080D-C8F7-6C8A-A441-2DD97BAE0E3B}"/>
-              </a:ext>
-            </a:extLst>
-          </p:cNvPr>
-          <p:cNvCxnSpPr>
-            <a:cxnSpLocks/>
-            <a:stCxn id="55" idx="4"/>
-          </p:cNvCxnSpPr>
-          <p:nvPr/>
-        </p:nvCxnSpPr>
-        <p:spPr>
-          <a:xfrm flipH="1">
-            <a:off x="10712875" y="3579761"/>
-            <a:ext cx="5179" cy="861142"/>
-          </a:xfrm>
-          <a:prstGeom prst="line">
-            <a:avLst/>
-          </a:prstGeom>
-        </p:spPr>
-        <p:style>
-          <a:lnRef idx="2">
-            <a:schemeClr val="dk1"/>
-          </a:lnRef>
-          <a:fillRef idx="0">
-            <a:schemeClr val="dk1"/>
-          </a:fillRef>
-          <a:effectRef idx="1">
-            <a:schemeClr val="dk1"/>
-          </a:effectRef>
-          <a:fontRef idx="minor">
-            <a:schemeClr val="tx1"/>
-          </a:fontRef>
-        </p:style>
-      </p:cxnSp>
-      <p:sp>
-        <p:nvSpPr>
-          <p:cNvPr id="57" name="TextBox 56">
-            <a:extLst>
-              <a:ext uri="{FF2B5EF4-FFF2-40B4-BE49-F238E27FC236}">
-                <a16:creationId xmlns:a16="http://schemas.microsoft.com/office/drawing/2014/main" id="{3C3234DD-9F4A-6546-003F-833B4D225C8C}"/>
-              </a:ext>
-            </a:extLst>
-          </p:cNvPr>
-          <p:cNvSpPr txBox="1"/>
-          <p:nvPr/>
-        </p:nvSpPr>
-        <p:spPr>
-          <a:xfrm>
-            <a:off x="10070175" y="4440903"/>
-            <a:ext cx="1295546" cy="923330"/>
-          </a:xfrm>
-          <a:prstGeom prst="rect">
-            <a:avLst/>
-          </a:prstGeom>
-          <a:noFill/>
-        </p:spPr>
-        <p:txBody>
-          <a:bodyPr wrap="none" rtlCol="0">
-            <a:spAutoFit/>
-          </a:bodyPr>
-          <a:lstStyle/>
-          <a:p>
-            <a:pPr algn="ctr"/>
-            <a:r>
-              <a:rPr lang="en-US" b="1"/>
-              <a:t>2018</a:t>
-            </a:r>
-          </a:p>
-          <a:p>
-            <a:pPr algn="ctr"/>
-            <a:r>
-              <a:rPr lang="en-US"/>
-              <a:t>Sự bùng nổ</a:t>
-            </a:r>
-          </a:p>
-          <a:p>
-            <a:pPr algn="ctr"/>
-            <a:r>
-              <a:rPr lang="en-US"/>
-              <a:t>của LLM</a:t>
-            </a:r>
-          </a:p>
-        </p:txBody>
-      </p:sp>
-      <p:sp>
-        <p:nvSpPr>
           <p:cNvPr id="58" name="TextBox 57">
             <a:extLst>
               <a:ext uri="{FF2B5EF4-FFF2-40B4-BE49-F238E27FC236}">
@@ -6477,6 +5825,42 @@
           </a:p>
         </p:txBody>
       </p:sp>
+      <p:pic>
+        <p:nvPicPr>
+          <p:cNvPr id="7" name="Picture 6" descr="A line of colorful circles&#10;&#10;AI-generated content may be incorrect.">
+            <a:extLst>
+              <a:ext uri="{FF2B5EF4-FFF2-40B4-BE49-F238E27FC236}">
+                <a16:creationId xmlns:a16="http://schemas.microsoft.com/office/drawing/2014/main" id="{A670133F-4560-3710-C873-80B0D2A347DC}"/>
+              </a:ext>
+            </a:extLst>
+          </p:cNvPr>
+          <p:cNvPicPr>
+            <a:picLocks noChangeAspect="1"/>
+          </p:cNvPicPr>
+          <p:nvPr/>
+        </p:nvPicPr>
+        <p:blipFill>
+          <a:blip r:embed="rId3">
+            <a:extLst>
+              <a:ext uri="{28A0092B-C50C-407E-A947-70E740481C1C}">
+                <a14:useLocalDpi xmlns:a14="http://schemas.microsoft.com/office/drawing/2010/main" val="0"/>
+              </a:ext>
+            </a:extLst>
+          </a:blip>
+          <a:stretch>
+            <a:fillRect/>
+          </a:stretch>
+        </p:blipFill>
+        <p:spPr>
+          <a:xfrm>
+            <a:off x="932329" y="1710087"/>
+            <a:ext cx="10327341" cy="3437825"/>
+          </a:xfrm>
+          <a:prstGeom prst="rect">
+            <a:avLst/>
+          </a:prstGeom>
+        </p:spPr>
+      </p:pic>
     </p:spTree>
     <p:extLst>
       <p:ext uri="{BB962C8B-B14F-4D97-AF65-F5344CB8AC3E}">
@@ -6507,130 +5891,42 @@
           <a:chExt cx="0" cy="0"/>
         </a:xfrm>
       </p:grpSpPr>
-      <p:sp>
-        <p:nvSpPr>
-          <p:cNvPr id="3" name="TextBox 2">
-            <a:extLst>
-              <a:ext uri="{FF2B5EF4-FFF2-40B4-BE49-F238E27FC236}">
-                <a16:creationId xmlns:a16="http://schemas.microsoft.com/office/drawing/2014/main" id="{4E5978E3-F900-CA23-529B-59D726ADBC9B}"/>
-              </a:ext>
-            </a:extLst>
-          </p:cNvPr>
-          <p:cNvSpPr txBox="1"/>
+      <p:pic>
+        <p:nvPicPr>
+          <p:cNvPr id="7" name="Picture 6" descr="A screenshot of a computer&#10;&#10;AI-generated content may be incorrect.">
+            <a:extLst>
+              <a:ext uri="{FF2B5EF4-FFF2-40B4-BE49-F238E27FC236}">
+                <a16:creationId xmlns:a16="http://schemas.microsoft.com/office/drawing/2014/main" id="{7913FD91-B87F-D541-223A-6032EB708B15}"/>
+              </a:ext>
+            </a:extLst>
+          </p:cNvPr>
+          <p:cNvPicPr>
+            <a:picLocks noChangeAspect="1"/>
+          </p:cNvPicPr>
           <p:nvPr/>
-        </p:nvSpPr>
+        </p:nvPicPr>
+        <p:blipFill>
+          <a:blip r:embed="rId3">
+            <a:extLst>
+              <a:ext uri="{28A0092B-C50C-407E-A947-70E740481C1C}">
+                <a14:useLocalDpi xmlns:a14="http://schemas.microsoft.com/office/drawing/2010/main" val="0"/>
+              </a:ext>
+            </a:extLst>
+          </a:blip>
+          <a:stretch>
+            <a:fillRect/>
+          </a:stretch>
+        </p:blipFill>
         <p:spPr>
           <a:xfrm>
-            <a:off x="9886950" y="1485900"/>
-            <a:ext cx="1151277" cy="369332"/>
+            <a:off x="-12886" y="-239911"/>
+            <a:ext cx="12217771" cy="7337822"/>
           </a:xfrm>
           <a:prstGeom prst="rect">
             <a:avLst/>
           </a:prstGeom>
-          <a:noFill/>
         </p:spPr>
-        <p:txBody>
-          <a:bodyPr wrap="none" rtlCol="0">
-            <a:spAutoFit/>
-          </a:bodyPr>
-          <a:lstStyle/>
-          <a:p>
-            <a:r>
-              <a:rPr lang="en-US"/>
-              <a:t>Chú thích</a:t>
-            </a:r>
-          </a:p>
-        </p:txBody>
-      </p:sp>
-      <p:sp>
-        <p:nvSpPr>
-          <p:cNvPr id="4" name="TextBox 3">
-            <a:extLst>
-              <a:ext uri="{FF2B5EF4-FFF2-40B4-BE49-F238E27FC236}">
-                <a16:creationId xmlns:a16="http://schemas.microsoft.com/office/drawing/2014/main" id="{8B84A2BE-AB3E-3655-E630-8375B72F27EC}"/>
-              </a:ext>
-            </a:extLst>
-          </p:cNvPr>
-          <p:cNvSpPr txBox="1"/>
-          <p:nvPr/>
-        </p:nvSpPr>
-        <p:spPr>
-          <a:xfrm>
-            <a:off x="666750" y="1855232"/>
-            <a:ext cx="10834569" cy="1754326"/>
-          </a:xfrm>
-          <a:prstGeom prst="rect">
-            <a:avLst/>
-          </a:prstGeom>
-          <a:noFill/>
-        </p:spPr>
-        <p:txBody>
-          <a:bodyPr wrap="none" rtlCol="0">
-            <a:spAutoFit/>
-          </a:bodyPr>
-          <a:lstStyle/>
-          <a:p>
-            <a:pPr marL="285750" indent="-285750">
-              <a:buFontTx/>
-              <a:buChar char="-"/>
-            </a:pPr>
-            <a:r>
-              <a:rPr lang="en-US"/>
-              <a:t>LLM là gì?</a:t>
-            </a:r>
-          </a:p>
-          <a:p>
-            <a:pPr marL="285750" indent="-285750">
-              <a:buFontTx/>
-              <a:buChar char="-"/>
-            </a:pPr>
-            <a:r>
-              <a:rPr lang="en-US"/>
-              <a:t>Tại sao lại gọi là LLM</a:t>
-            </a:r>
-          </a:p>
-          <a:p>
-            <a:pPr marL="285750" indent="-285750">
-              <a:buFontTx/>
-              <a:buChar char="-"/>
-            </a:pPr>
-            <a:r>
-              <a:rPr lang="en-US"/>
-              <a:t>Dựa trên nguyên lý? (xây dựng dựa trên transformer làm mô hình cơ sở, tuy nhiên thì có chút biến đổi)</a:t>
-            </a:r>
-          </a:p>
-          <a:p>
-            <a:pPr marL="285750" indent="-285750">
-              <a:buFontTx/>
-              <a:buChar char="-"/>
-            </a:pPr>
-            <a:r>
-              <a:rPr lang="en-US"/>
-              <a:t>Nó có thể làm gì? (sinh văn bản, xử lý âm thanh, video…)</a:t>
-            </a:r>
-          </a:p>
-          <a:p>
-            <a:pPr marL="285750" indent="-285750">
-              <a:buFontTx/>
-              <a:buChar char="-"/>
-            </a:pPr>
-            <a:r>
-              <a:rPr lang="en-US"/>
-              <a:t>Kể ra một vài thông số (LLM có thể lên tới hang tỉ tham số, chi phí huấn luyện khổng lồ, kiến trúc phức tạp)</a:t>
-            </a:r>
-          </a:p>
-          <a:p>
-            <a:pPr marL="285750" indent="-285750">
-              <a:buFontTx/>
-              <a:buChar char="-"/>
-            </a:pPr>
-            <a:r>
-              <a:rPr lang="en-US"/>
-              <a:t>chèn hình LLM</a:t>
-            </a:r>
-          </a:p>
-        </p:txBody>
-      </p:sp>
+      </p:pic>
     </p:spTree>
     <p:extLst>
       <p:ext uri="{BB962C8B-B14F-4D97-AF65-F5344CB8AC3E}">
@@ -6661,85 +5957,42 @@
           <a:chExt cx="0" cy="0"/>
         </a:xfrm>
       </p:grpSpPr>
-      <p:sp>
-        <p:nvSpPr>
-          <p:cNvPr id="2" name="TextBox 1">
-            <a:extLst>
-              <a:ext uri="{FF2B5EF4-FFF2-40B4-BE49-F238E27FC236}">
-                <a16:creationId xmlns:a16="http://schemas.microsoft.com/office/drawing/2014/main" id="{5194C927-510B-47DE-D634-D22B44D4AA2E}"/>
-              </a:ext>
-            </a:extLst>
-          </p:cNvPr>
-          <p:cNvSpPr txBox="1"/>
+      <p:pic>
+        <p:nvPicPr>
+          <p:cNvPr id="4" name="Picture 3" descr="A diagram of a software model&#10;&#10;AI-generated content may be incorrect.">
+            <a:extLst>
+              <a:ext uri="{FF2B5EF4-FFF2-40B4-BE49-F238E27FC236}">
+                <a16:creationId xmlns:a16="http://schemas.microsoft.com/office/drawing/2014/main" id="{025959DD-CF58-9169-6EB0-EDEB8CE88814}"/>
+              </a:ext>
+            </a:extLst>
+          </p:cNvPr>
+          <p:cNvPicPr>
+            <a:picLocks noChangeAspect="1"/>
+          </p:cNvPicPr>
           <p:nvPr/>
-        </p:nvSpPr>
+        </p:nvPicPr>
+        <p:blipFill>
+          <a:blip r:embed="rId3">
+            <a:extLst>
+              <a:ext uri="{28A0092B-C50C-407E-A947-70E740481C1C}">
+                <a14:useLocalDpi xmlns:a14="http://schemas.microsoft.com/office/drawing/2010/main" val="0"/>
+              </a:ext>
+            </a:extLst>
+          </a:blip>
+          <a:stretch>
+            <a:fillRect/>
+          </a:stretch>
+        </p:blipFill>
         <p:spPr>
           <a:xfrm>
-            <a:off x="823338" y="1951672"/>
-            <a:ext cx="10545323" cy="1477328"/>
+            <a:off x="774601" y="723293"/>
+            <a:ext cx="10642797" cy="5411413"/>
           </a:xfrm>
           <a:prstGeom prst="rect">
             <a:avLst/>
           </a:prstGeom>
-          <a:noFill/>
         </p:spPr>
-        <p:txBody>
-          <a:bodyPr wrap="none" rtlCol="0">
-            <a:spAutoFit/>
-          </a:bodyPr>
-          <a:lstStyle/>
-          <a:p>
-            <a:pPr marL="285750" indent="-285750">
-              <a:buFontTx/>
-              <a:buChar char="-"/>
-            </a:pPr>
-            <a:r>
-              <a:rPr lang="en-US"/>
-              <a:t>Hệ thống RAG là gì?</a:t>
-            </a:r>
-          </a:p>
-          <a:p>
-            <a:pPr marL="285750" indent="-285750">
-              <a:buFontTx/>
-              <a:buChar char="-"/>
-            </a:pPr>
-            <a:r>
-              <a:rPr lang="en-US"/>
-              <a:t>Tác dụng?</a:t>
-            </a:r>
-          </a:p>
-          <a:p>
-            <a:pPr marL="285750" indent="-285750">
-              <a:buFontTx/>
-              <a:buChar char="-"/>
-            </a:pPr>
-            <a:r>
-              <a:rPr lang="en-US"/>
-              <a:t>LLM được sử dụng trong hệ thống rag như thế nào?</a:t>
-            </a:r>
-          </a:p>
-          <a:p>
-            <a:pPr marL="285750" indent="-285750">
-              <a:buFontTx/>
-              <a:buChar char="-"/>
-            </a:pPr>
-            <a:r>
-              <a:rPr lang="en-US"/>
-              <a:t>Sử dụng LLM và hệ thống rag để xây dựng chatbot hõ trợ học lịch sử việt nam</a:t>
-            </a:r>
-          </a:p>
-          <a:p>
-            <a:pPr marL="285750" indent="-285750">
-              <a:buFontTx/>
-              <a:buChar char="-"/>
-            </a:pPr>
-            <a:r>
-              <a:rPr lang="en-US"/>
-              <a:t> (tại sao 2 cái đó lại có thể sử dụng để xây dung chatbot? Lợi tích so với các phương pháp truyền thống)</a:t>
-            </a:r>
-          </a:p>
-        </p:txBody>
-      </p:sp>
+      </p:pic>
     </p:spTree>
     <p:extLst>
       <p:ext uri="{BB962C8B-B14F-4D97-AF65-F5344CB8AC3E}">
@@ -6970,62 +6223,42 @@
           <a:chExt cx="0" cy="0"/>
         </a:xfrm>
       </p:grpSpPr>
-      <p:sp>
-        <p:nvSpPr>
-          <p:cNvPr id="2" name="TextBox 1">
-            <a:extLst>
-              <a:ext uri="{FF2B5EF4-FFF2-40B4-BE49-F238E27FC236}">
-                <a16:creationId xmlns:a16="http://schemas.microsoft.com/office/drawing/2014/main" id="{3E28C3E0-7451-F051-7635-94E578292DF8}"/>
-              </a:ext>
-            </a:extLst>
-          </p:cNvPr>
-          <p:cNvSpPr txBox="1"/>
+      <p:pic>
+        <p:nvPicPr>
+          <p:cNvPr id="4" name="Picture 3" descr="A black background with white text&#10;&#10;AI-generated content may be incorrect.">
+            <a:extLst>
+              <a:ext uri="{FF2B5EF4-FFF2-40B4-BE49-F238E27FC236}">
+                <a16:creationId xmlns:a16="http://schemas.microsoft.com/office/drawing/2014/main" id="{639464A9-8ACE-E2AB-1F57-892582DE6A6A}"/>
+              </a:ext>
+            </a:extLst>
+          </p:cNvPr>
+          <p:cNvPicPr>
+            <a:picLocks noChangeAspect="1"/>
+          </p:cNvPicPr>
           <p:nvPr/>
-        </p:nvSpPr>
+        </p:nvPicPr>
+        <p:blipFill>
+          <a:blip r:embed="rId3">
+            <a:extLst>
+              <a:ext uri="{28A0092B-C50C-407E-A947-70E740481C1C}">
+                <a14:useLocalDpi xmlns:a14="http://schemas.microsoft.com/office/drawing/2010/main" val="0"/>
+              </a:ext>
+            </a:extLst>
+          </a:blip>
+          <a:stretch>
+            <a:fillRect/>
+          </a:stretch>
+        </p:blipFill>
         <p:spPr>
           <a:xfrm>
-            <a:off x="2571750" y="2667000"/>
-            <a:ext cx="5210337" cy="923330"/>
+            <a:off x="806500" y="183112"/>
+            <a:ext cx="10578999" cy="6491776"/>
           </a:xfrm>
           <a:prstGeom prst="rect">
             <a:avLst/>
           </a:prstGeom>
-          <a:noFill/>
         </p:spPr>
-        <p:txBody>
-          <a:bodyPr wrap="none" rtlCol="0">
-            <a:spAutoFit/>
-          </a:bodyPr>
-          <a:lstStyle/>
-          <a:p>
-            <a:pPr marL="285750" indent="-285750">
-              <a:buFontTx/>
-              <a:buChar char="-"/>
-            </a:pPr>
-            <a:r>
-              <a:rPr lang="en-US"/>
-              <a:t>Phương pháp đề xuất</a:t>
-            </a:r>
-          </a:p>
-          <a:p>
-            <a:pPr marL="285750" indent="-285750">
-              <a:buFontTx/>
-              <a:buChar char="-"/>
-            </a:pPr>
-            <a:r>
-              <a:rPr lang="en-US"/>
-              <a:t>Chèn hình, miêu tả chi tiết phương pháp đề xuất</a:t>
-            </a:r>
-          </a:p>
-          <a:p>
-            <a:pPr marL="285750" indent="-285750">
-              <a:buFontTx/>
-              <a:buChar char="-"/>
-            </a:pPr>
-            <a:endParaRPr lang="en-US"/>
-          </a:p>
-        </p:txBody>
-      </p:sp>
+      </p:pic>
     </p:spTree>
     <p:extLst>
       <p:ext uri="{BB962C8B-B14F-4D97-AF65-F5344CB8AC3E}">
@@ -7062,45 +6295,42 @@
           <a:chExt cx="0" cy="0"/>
         </a:xfrm>
       </p:grpSpPr>
-      <p:sp>
-        <p:nvSpPr>
-          <p:cNvPr id="2" name="TextBox 1">
-            <a:extLst>
-              <a:ext uri="{FF2B5EF4-FFF2-40B4-BE49-F238E27FC236}">
-                <a16:creationId xmlns:a16="http://schemas.microsoft.com/office/drawing/2014/main" id="{8AE17E17-E980-B51F-713B-33484F322492}"/>
-              </a:ext>
-            </a:extLst>
-          </p:cNvPr>
-          <p:cNvSpPr txBox="1"/>
+      <p:pic>
+        <p:nvPicPr>
+          <p:cNvPr id="4" name="Picture 3" descr="A screenshot of a computer screen&#10;&#10;AI-generated content may be incorrect.">
+            <a:extLst>
+              <a:ext uri="{FF2B5EF4-FFF2-40B4-BE49-F238E27FC236}">
+                <a16:creationId xmlns:a16="http://schemas.microsoft.com/office/drawing/2014/main" id="{B2EA4F12-5E6C-115B-1FC5-640B3BC0BFE9}"/>
+              </a:ext>
+            </a:extLst>
+          </p:cNvPr>
+          <p:cNvPicPr>
+            <a:picLocks noChangeAspect="1"/>
+          </p:cNvPicPr>
           <p:nvPr/>
-        </p:nvSpPr>
+        </p:nvPicPr>
+        <p:blipFill>
+          <a:blip r:embed="rId3">
+            <a:extLst>
+              <a:ext uri="{28A0092B-C50C-407E-A947-70E740481C1C}">
+                <a14:useLocalDpi xmlns:a14="http://schemas.microsoft.com/office/drawing/2010/main" val="0"/>
+              </a:ext>
+            </a:extLst>
+          </a:blip>
+          <a:stretch>
+            <a:fillRect/>
+          </a:stretch>
+        </p:blipFill>
         <p:spPr>
           <a:xfrm>
-            <a:off x="2571750" y="2667000"/>
-            <a:ext cx="2497607" cy="369332"/>
+            <a:off x="857066" y="165538"/>
+            <a:ext cx="10477868" cy="6526924"/>
           </a:xfrm>
           <a:prstGeom prst="rect">
             <a:avLst/>
           </a:prstGeom>
-          <a:noFill/>
         </p:spPr>
-        <p:txBody>
-          <a:bodyPr wrap="none" rtlCol="0">
-            <a:spAutoFit/>
-          </a:bodyPr>
-          <a:lstStyle/>
-          <a:p>
-            <a:pPr marL="285750" indent="-285750">
-              <a:buFontTx/>
-              <a:buChar char="-"/>
-            </a:pPr>
-            <a:r>
-              <a:rPr lang="en-US"/>
-              <a:t>Hệ thống rag đề xuất</a:t>
-            </a:r>
-          </a:p>
-        </p:txBody>
-      </p:sp>
+      </p:pic>
     </p:spTree>
     <p:extLst>
       <p:ext uri="{BB962C8B-B14F-4D97-AF65-F5344CB8AC3E}">

</xml_diff>